<commit_message>
Redraw ERD at conceptual level and rename PHONGCHIEU.SoGhe to SucChua
- ERD now uses relationship diamonds with 1/N cardinalities and lists only
  real attributes (no foreign keys); N-N relationships are explained via
  associative entities VE and SUATCHIEU.
- Relational schema on slide 4 is generated from the same model.
- PHONGCHIEU.SoGhe (capacity) renamed to SucChua; VE.SoGhe (seat label) kept,
  so one column name no longer carries two meanings.

Co-Authored-By: Claude Sonnet 5.5 <noreply@anthropic.com>
Claude-Session: https://claude.ai/code/session_01Mv7zheFMCNi8CpghoGk7yL
</commit_message>
<xml_diff>
--- a/hqtcsdl-giuaky/quan_ly_rap_phim.pptx
+++ b/hqtcsdl-giuaky/quan_ly_rap_phim.pptx
@@ -111,19 +111,19 @@
   <p:extLst>
     <p:ext uri="{521415D9-36F7-43E2-AB2F-B90AF26B5E84}">
       <p14:sectionLst xmlns:p14="http://schemas.microsoft.com/office/powerpoint/2010/main">
-        <p14:section name="Mở đầu" id="{54fd1444-01a9-b123-9869-c660c24e7b6a}">
+        <p14:section name="Mở đầu" id="{3aeb8774-7bba-6b95-b253-9a1b377049b4}">
           <p14:sldIdLst>
             <p14:sldId id="256"/>
             <p14:sldId id="257"/>
           </p14:sldIdLst>
         </p14:section>
-        <p14:section name="Thiết kế cơ sở dữ liệu" id="{69461afd-3e79-a89a-90a7-f47577d6779e}">
+        <p14:section name="Thiết kế cơ sở dữ liệu" id="{521103c3-6c4f-00a3-7c7f-179e7b2fb6fa}">
           <p14:sldIdLst>
             <p14:sldId id="258"/>
             <p14:sldId id="259"/>
           </p14:sldIdLst>
         </p14:section>
-        <p14:section name="Kết thúc" id="{1aeff8f6-1150-a85a-b34b-3724b8d5c2af}">
+        <p14:section name="Kết thúc" id="{7108480f-b136-d509-07cb-7087ccadc9cc}">
           <p14:sldIdLst>
             <p14:sldId id="260"/>
           </p14:sldIdLst>
@@ -708,7 +708,7 @@
           <a:p>
             <a:r>
               <a:rPr lang="en-US" dirty="0"/>
-              <a:t>Slide 3 - Mô tả bài toán và ERD. Nêu 5 thực thể: PHIM, PHONGCHIEU, SUATCHIEU, KHACHHANG, VE. Quan hệ: PHIM 1-N SUATCHIEU, PHONGCHIEU 1-N SUATCHIEU, KHACHHANG 1-N VE, SUATCHIEU 1-N VE. Giữa KHACHHANG và SUATCHIEU là quan hệ nhiều-nhiều (một khách đặt nhiều suất, một suất có nhiều khách) nên tách bằng bảng VE. Tương tự PHIM và PHONGCHIEU là nhiều-nhiều qua SUATCHIEU.</a:t>
+              <a:t>Slide 3 - Mô tả bài toán và ERD. Có 5 thực thể: PHIM, PHONGCHIEU, SUATCHIEU, KHACHHANG, VE (khóa chính được gạch chân). Quan hệ: PHIM 1-N SUATCHIEU (chiếu), PHONGCHIEU 1-N SUATCHIEU (tại), SUATCHIEU 1-N VE (bán), KHACHHANG 1-N VE (đặt). Giữa KHACHHANG và SUATCHIEU là quan hệ nhiều-nhiều (một khách đặt nhiều suất, một suất có nhiều khách) nên cần thực thể kết hợp VE; tương tự PHIM và PHONGCHIEU là nhiều-nhiều qua SUATCHIEU. ERD không ghi khóa ngoại; khóa ngoại xuất hiện khi chuyển sang lược đồ quan hệ ở slide 4.</a:t>
             </a:r>
             <a:endParaRPr lang="en-US" dirty="0"/>
           </a:p>
@@ -796,7 +796,7 @@
           <a:p>
             <a:r>
               <a:rPr lang="en-US" dirty="0"/>
-              <a:t>Slide 4 - Lược đồ CSDL: khóa chính gạch chân, khóa ngoại in nghiêng. Dữ liệu mẫu được nhập bằng file quan_ly_rap_phim.sql trong MySQL; có thể thay các bảng bên phải bằng ảnh chụp màn hình kết quả SELECT trong MySQL Workbench. Ràng buộc: khóa chính, khóa ngoại, miền giá trị (CHECK), UNIQUE.</a:t>
+              <a:t>Slide 4 - Lược đồ CSDL được chuyển từ ERD: mỗi thực thể thành một bảng, quan hệ 1-N thành khóa ngoại ở phía N. Khóa chính gạch chân, khóa ngoại in nghiêng. Dữ liệu mẫu được nhập bằng file quan_ly_rap_phim.sql trong MySQL; có thể thay các bảng bên phải bằng ảnh chụp màn hình kết quả SELECT trong MySQL Workbench. Ràng buộc: khóa chính, khóa ngoại, miền giá trị (CHECK), UNIQUE.</a:t>
             </a:r>
             <a:endParaRPr lang="en-US" dirty="0"/>
           </a:p>
@@ -3298,7 +3298,7 @@
                   <a:schemeClr val="tx1"/>
                 </a:solidFill>
               </a:rPr>
-              <a:t>Phòng chiếu có tên, loại phòng, số ghế</a:t>
+              <a:t>Phòng chiếu có tên, loại phòng, sức chứa</a:t>
             </a:r>
             <a:endParaRPr lang="en-US" sz="1800" dirty="0"/>
           </a:p>
@@ -3410,7 +3410,7 @@
                   <a:schemeClr val="tx1"/>
                 </a:solidFill>
               </a:rPr>
-              <a:t>Mỗi vé thuộc một khách hàng và một suất chiếu</a:t>
+              <a:t>Mỗi vé có số ghế, ngày đặt; thuộc một khách hàng và một suất chiếu</a:t>
             </a:r>
             <a:endParaRPr lang="en-US" sz="1800" dirty="0"/>
           </a:p>
@@ -3418,14 +3418,562 @@
       </p:sp>
       <p:sp>
         <p:nvSpPr>
-          <p:cNvPr id="5" name="PHIM body"/>
+          <p:cNvPr id="5" name="Line PHIM-SUATCHIEU"/>
+          <p:cNvSpPr/>
+          <p:nvPr/>
+        </p:nvSpPr>
+        <p:spPr>
+          <a:xfrm>
+            <a:off x="5916168" y="2171700"/>
+            <a:ext cx="1380744" cy="0"/>
+          </a:xfrm>
+          <a:prstGeom prst="line">
+            <a:avLst/>
+          </a:prstGeom>
+          <a:noFill/>
+          <a:ln w="22225">
+            <a:solidFill>
+              <a:schemeClr val="tx1"/>
+            </a:solidFill>
+            <a:prstDash val="solid"/>
+          </a:ln>
+        </p:spPr>
+      </p:sp>
+      <p:sp>
+        <p:nvSpPr>
+          <p:cNvPr id="6" name="Relationship PHIM-SUATCHIEU"/>
+          <p:cNvSpPr/>
+          <p:nvPr/>
+        </p:nvSpPr>
+        <p:spPr>
+          <a:xfrm>
+            <a:off x="6149340" y="1888236"/>
+            <a:ext cx="914400" cy="566928"/>
+          </a:xfrm>
+          <a:prstGeom prst="diamond">
+            <a:avLst/>
+          </a:prstGeom>
+          <a:solidFill>
+            <a:schemeClr val="bg1"/>
+          </a:solidFill>
+          <a:ln w="15875">
+            <a:solidFill>
+              <a:schemeClr val="tx1"/>
+            </a:solidFill>
+          </a:ln>
+        </p:spPr>
+        <p:txBody>
+          <a:bodyPr wrap="square" lIns="0" tIns="0" rIns="0" bIns="0" rtlCol="0" anchor="ctr"/>
+          <a:lstStyle/>
+          <a:p>
+            <a:pPr algn="ctr" indent="0" marL="0">
+              <a:buNone/>
+            </a:pPr>
+            <a:r>
+              <a:rPr lang="en-US" sz="1050" b="1" dirty="0">
+                <a:solidFill>
+                  <a:schemeClr val="tx1"/>
+                </a:solidFill>
+              </a:rPr>
+              <a:t>chiếu</a:t>
+            </a:r>
+            <a:endParaRPr lang="en-US" sz="1050" dirty="0"/>
+          </a:p>
+        </p:txBody>
+      </p:sp>
+      <p:sp>
+        <p:nvSpPr>
+          <p:cNvPr id="7" name="Cardinality 1"/>
+          <p:cNvSpPr txBox="1"/>
+          <p:nvPr/>
+        </p:nvSpPr>
+        <p:spPr>
+          <a:xfrm>
+            <a:off x="5943600" y="1924812"/>
+            <a:ext cx="201168" cy="219456"/>
+          </a:xfrm>
+          <a:prstGeom prst="rect">
+            <a:avLst/>
+          </a:prstGeom>
+          <a:noFill/>
+          <a:ln/>
+        </p:spPr>
+        <p:txBody>
+          <a:bodyPr wrap="square" lIns="0" tIns="0" rIns="0" bIns="0" rtlCol="0" anchor="t"/>
+          <a:lstStyle/>
+          <a:p>
+            <a:pPr algn="l" indent="0" marL="0">
+              <a:buNone/>
+            </a:pPr>
+            <a:r>
+              <a:rPr lang="en-US" sz="1100" b="1" dirty="0">
+                <a:solidFill>
+                  <a:schemeClr val="tx1"/>
+                </a:solidFill>
+              </a:rPr>
+              <a:t>1</a:t>
+            </a:r>
+            <a:endParaRPr lang="en-US" sz="1100" dirty="0"/>
+          </a:p>
+        </p:txBody>
+      </p:sp>
+      <p:sp>
+        <p:nvSpPr>
+          <p:cNvPr id="8" name="Cardinality N"/>
+          <p:cNvSpPr txBox="1"/>
+          <p:nvPr/>
+        </p:nvSpPr>
+        <p:spPr>
+          <a:xfrm>
+            <a:off x="7068312" y="1924812"/>
+            <a:ext cx="201168" cy="219456"/>
+          </a:xfrm>
+          <a:prstGeom prst="rect">
+            <a:avLst/>
+          </a:prstGeom>
+          <a:noFill/>
+          <a:ln/>
+        </p:spPr>
+        <p:txBody>
+          <a:bodyPr wrap="square" lIns="0" tIns="0" rIns="0" bIns="0" rtlCol="0" anchor="t"/>
+          <a:lstStyle/>
+          <a:p>
+            <a:pPr algn="r" indent="0" marL="0">
+              <a:buNone/>
+            </a:pPr>
+            <a:r>
+              <a:rPr lang="en-US" sz="1100" b="1" dirty="0">
+                <a:solidFill>
+                  <a:schemeClr val="tx1"/>
+                </a:solidFill>
+              </a:rPr>
+              <a:t>N</a:t>
+            </a:r>
+            <a:endParaRPr lang="en-US" sz="1100" dirty="0"/>
+          </a:p>
+        </p:txBody>
+      </p:sp>
+      <p:sp>
+        <p:nvSpPr>
+          <p:cNvPr id="9" name="Line PHONGCHIEU-SUATCHIEU"/>
+          <p:cNvSpPr/>
+          <p:nvPr/>
+        </p:nvSpPr>
+        <p:spPr>
+          <a:xfrm>
+            <a:off x="8823960" y="2171700"/>
+            <a:ext cx="1380744" cy="0"/>
+          </a:xfrm>
+          <a:prstGeom prst="line">
+            <a:avLst/>
+          </a:prstGeom>
+          <a:noFill/>
+          <a:ln w="22225">
+            <a:solidFill>
+              <a:schemeClr val="tx1"/>
+            </a:solidFill>
+            <a:prstDash val="solid"/>
+          </a:ln>
+        </p:spPr>
+      </p:sp>
+      <p:sp>
+        <p:nvSpPr>
+          <p:cNvPr id="10" name="Relationship PHONGCHIEU-SUATCHIEU"/>
+          <p:cNvSpPr/>
+          <p:nvPr/>
+        </p:nvSpPr>
+        <p:spPr>
+          <a:xfrm>
+            <a:off x="9057132" y="1888236"/>
+            <a:ext cx="914400" cy="566928"/>
+          </a:xfrm>
+          <a:prstGeom prst="diamond">
+            <a:avLst/>
+          </a:prstGeom>
+          <a:solidFill>
+            <a:schemeClr val="bg1"/>
+          </a:solidFill>
+          <a:ln w="15875">
+            <a:solidFill>
+              <a:schemeClr val="tx1"/>
+            </a:solidFill>
+          </a:ln>
+        </p:spPr>
+        <p:txBody>
+          <a:bodyPr wrap="square" lIns="0" tIns="0" rIns="0" bIns="0" rtlCol="0" anchor="ctr"/>
+          <a:lstStyle/>
+          <a:p>
+            <a:pPr algn="ctr" indent="0" marL="0">
+              <a:buNone/>
+            </a:pPr>
+            <a:r>
+              <a:rPr lang="en-US" sz="1050" b="1" dirty="0">
+                <a:solidFill>
+                  <a:schemeClr val="tx1"/>
+                </a:solidFill>
+              </a:rPr>
+              <a:t>tại</a:t>
+            </a:r>
+            <a:endParaRPr lang="en-US" sz="1050" dirty="0"/>
+          </a:p>
+        </p:txBody>
+      </p:sp>
+      <p:sp>
+        <p:nvSpPr>
+          <p:cNvPr id="11" name="Cardinality N"/>
+          <p:cNvSpPr txBox="1"/>
+          <p:nvPr/>
+        </p:nvSpPr>
+        <p:spPr>
+          <a:xfrm>
+            <a:off x="8851392" y="1924812"/>
+            <a:ext cx="201168" cy="219456"/>
+          </a:xfrm>
+          <a:prstGeom prst="rect">
+            <a:avLst/>
+          </a:prstGeom>
+          <a:noFill/>
+          <a:ln/>
+        </p:spPr>
+        <p:txBody>
+          <a:bodyPr wrap="square" lIns="0" tIns="0" rIns="0" bIns="0" rtlCol="0" anchor="t"/>
+          <a:lstStyle/>
+          <a:p>
+            <a:pPr algn="l" indent="0" marL="0">
+              <a:buNone/>
+            </a:pPr>
+            <a:r>
+              <a:rPr lang="en-US" sz="1100" b="1" dirty="0">
+                <a:solidFill>
+                  <a:schemeClr val="tx1"/>
+                </a:solidFill>
+              </a:rPr>
+              <a:t>N</a:t>
+            </a:r>
+            <a:endParaRPr lang="en-US" sz="1100" dirty="0"/>
+          </a:p>
+        </p:txBody>
+      </p:sp>
+      <p:sp>
+        <p:nvSpPr>
+          <p:cNvPr id="12" name="Cardinality 1"/>
+          <p:cNvSpPr txBox="1"/>
+          <p:nvPr/>
+        </p:nvSpPr>
+        <p:spPr>
+          <a:xfrm>
+            <a:off x="9976104" y="1924812"/>
+            <a:ext cx="201168" cy="219456"/>
+          </a:xfrm>
+          <a:prstGeom prst="rect">
+            <a:avLst/>
+          </a:prstGeom>
+          <a:noFill/>
+          <a:ln/>
+        </p:spPr>
+        <p:txBody>
+          <a:bodyPr wrap="square" lIns="0" tIns="0" rIns="0" bIns="0" rtlCol="0" anchor="t"/>
+          <a:lstStyle/>
+          <a:p>
+            <a:pPr algn="r" indent="0" marL="0">
+              <a:buNone/>
+            </a:pPr>
+            <a:r>
+              <a:rPr lang="en-US" sz="1100" b="1" dirty="0">
+                <a:solidFill>
+                  <a:schemeClr val="tx1"/>
+                </a:solidFill>
+              </a:rPr>
+              <a:t>1</a:t>
+            </a:r>
+            <a:endParaRPr lang="en-US" sz="1100" dirty="0"/>
+          </a:p>
+        </p:txBody>
+      </p:sp>
+      <p:sp>
+        <p:nvSpPr>
+          <p:cNvPr id="13" name="Line SUATCHIEU-VE"/>
+          <p:cNvSpPr/>
+          <p:nvPr/>
+        </p:nvSpPr>
+        <p:spPr>
+          <a:xfrm>
+            <a:off x="8060436" y="2971800"/>
+            <a:ext cx="0" cy="1097280"/>
+          </a:xfrm>
+          <a:prstGeom prst="line">
+            <a:avLst/>
+          </a:prstGeom>
+          <a:noFill/>
+          <a:ln w="22225">
+            <a:solidFill>
+              <a:schemeClr val="tx1"/>
+            </a:solidFill>
+            <a:prstDash val="solid"/>
+          </a:ln>
+        </p:spPr>
+      </p:sp>
+      <p:sp>
+        <p:nvSpPr>
+          <p:cNvPr id="14" name="Relationship SUATCHIEU-VE"/>
+          <p:cNvSpPr/>
+          <p:nvPr/>
+        </p:nvSpPr>
+        <p:spPr>
+          <a:xfrm>
+            <a:off x="7603236" y="3236976"/>
+            <a:ext cx="914400" cy="566928"/>
+          </a:xfrm>
+          <a:prstGeom prst="diamond">
+            <a:avLst/>
+          </a:prstGeom>
+          <a:solidFill>
+            <a:schemeClr val="bg1"/>
+          </a:solidFill>
+          <a:ln w="15875">
+            <a:solidFill>
+              <a:schemeClr val="tx1"/>
+            </a:solidFill>
+          </a:ln>
+        </p:spPr>
+        <p:txBody>
+          <a:bodyPr wrap="square" lIns="0" tIns="0" rIns="0" bIns="0" rtlCol="0" anchor="ctr"/>
+          <a:lstStyle/>
+          <a:p>
+            <a:pPr algn="ctr" indent="0" marL="0">
+              <a:buNone/>
+            </a:pPr>
+            <a:r>
+              <a:rPr lang="en-US" sz="1050" b="1" dirty="0">
+                <a:solidFill>
+                  <a:schemeClr val="tx1"/>
+                </a:solidFill>
+              </a:rPr>
+              <a:t>bán</a:t>
+            </a:r>
+            <a:endParaRPr lang="en-US" sz="1050" dirty="0"/>
+          </a:p>
+        </p:txBody>
+      </p:sp>
+      <p:sp>
+        <p:nvSpPr>
+          <p:cNvPr id="15" name="Cardinality 1"/>
+          <p:cNvSpPr txBox="1"/>
+          <p:nvPr/>
+        </p:nvSpPr>
+        <p:spPr>
+          <a:xfrm>
+            <a:off x="7786116" y="2999232"/>
+            <a:ext cx="201168" cy="219456"/>
+          </a:xfrm>
+          <a:prstGeom prst="rect">
+            <a:avLst/>
+          </a:prstGeom>
+          <a:noFill/>
+          <a:ln/>
+        </p:spPr>
+        <p:txBody>
+          <a:bodyPr wrap="square" lIns="0" tIns="0" rIns="0" bIns="0" rtlCol="0" anchor="t"/>
+          <a:lstStyle/>
+          <a:p>
+            <a:pPr algn="r" indent="0" marL="0">
+              <a:buNone/>
+            </a:pPr>
+            <a:r>
+              <a:rPr lang="en-US" sz="1100" b="1" dirty="0">
+                <a:solidFill>
+                  <a:schemeClr val="tx1"/>
+                </a:solidFill>
+              </a:rPr>
+              <a:t>1</a:t>
+            </a:r>
+            <a:endParaRPr lang="en-US" sz="1100" dirty="0"/>
+          </a:p>
+        </p:txBody>
+      </p:sp>
+      <p:sp>
+        <p:nvSpPr>
+          <p:cNvPr id="16" name="Cardinality N"/>
+          <p:cNvSpPr txBox="1"/>
+          <p:nvPr/>
+        </p:nvSpPr>
+        <p:spPr>
+          <a:xfrm>
+            <a:off x="7786116" y="3822192"/>
+            <a:ext cx="201168" cy="219456"/>
+          </a:xfrm>
+          <a:prstGeom prst="rect">
+            <a:avLst/>
+          </a:prstGeom>
+          <a:noFill/>
+          <a:ln/>
+        </p:spPr>
+        <p:txBody>
+          <a:bodyPr wrap="square" lIns="0" tIns="0" rIns="0" bIns="0" rtlCol="0" anchor="t"/>
+          <a:lstStyle/>
+          <a:p>
+            <a:pPr algn="r" indent="0" marL="0">
+              <a:buNone/>
+            </a:pPr>
+            <a:r>
+              <a:rPr lang="en-US" sz="1100" b="1" dirty="0">
+                <a:solidFill>
+                  <a:schemeClr val="tx1"/>
+                </a:solidFill>
+              </a:rPr>
+              <a:t>N</a:t>
+            </a:r>
+            <a:endParaRPr lang="en-US" sz="1100" dirty="0"/>
+          </a:p>
+        </p:txBody>
+      </p:sp>
+      <p:sp>
+        <p:nvSpPr>
+          <p:cNvPr id="17" name="Line KHACHHANG-VE"/>
+          <p:cNvSpPr/>
+          <p:nvPr/>
+        </p:nvSpPr>
+        <p:spPr>
+          <a:xfrm>
+            <a:off x="5916168" y="4777740"/>
+            <a:ext cx="1380744" cy="0"/>
+          </a:xfrm>
+          <a:prstGeom prst="line">
+            <a:avLst/>
+          </a:prstGeom>
+          <a:noFill/>
+          <a:ln w="22225">
+            <a:solidFill>
+              <a:schemeClr val="tx1"/>
+            </a:solidFill>
+            <a:prstDash val="solid"/>
+          </a:ln>
+        </p:spPr>
+      </p:sp>
+      <p:sp>
+        <p:nvSpPr>
+          <p:cNvPr id="18" name="Relationship KHACHHANG-VE"/>
+          <p:cNvSpPr/>
+          <p:nvPr/>
+        </p:nvSpPr>
+        <p:spPr>
+          <a:xfrm>
+            <a:off x="6149340" y="4494276"/>
+            <a:ext cx="914400" cy="566928"/>
+          </a:xfrm>
+          <a:prstGeom prst="diamond">
+            <a:avLst/>
+          </a:prstGeom>
+          <a:solidFill>
+            <a:schemeClr val="bg1"/>
+          </a:solidFill>
+          <a:ln w="15875">
+            <a:solidFill>
+              <a:schemeClr val="tx1"/>
+            </a:solidFill>
+          </a:ln>
+        </p:spPr>
+        <p:txBody>
+          <a:bodyPr wrap="square" lIns="0" tIns="0" rIns="0" bIns="0" rtlCol="0" anchor="ctr"/>
+          <a:lstStyle/>
+          <a:p>
+            <a:pPr algn="ctr" indent="0" marL="0">
+              <a:buNone/>
+            </a:pPr>
+            <a:r>
+              <a:rPr lang="en-US" sz="1050" b="1" dirty="0">
+                <a:solidFill>
+                  <a:schemeClr val="tx1"/>
+                </a:solidFill>
+              </a:rPr>
+              <a:t>đặt</a:t>
+            </a:r>
+            <a:endParaRPr lang="en-US" sz="1050" dirty="0"/>
+          </a:p>
+        </p:txBody>
+      </p:sp>
+      <p:sp>
+        <p:nvSpPr>
+          <p:cNvPr id="19" name="Cardinality 1"/>
+          <p:cNvSpPr txBox="1"/>
+          <p:nvPr/>
+        </p:nvSpPr>
+        <p:spPr>
+          <a:xfrm>
+            <a:off x="5943600" y="4530852"/>
+            <a:ext cx="201168" cy="219456"/>
+          </a:xfrm>
+          <a:prstGeom prst="rect">
+            <a:avLst/>
+          </a:prstGeom>
+          <a:noFill/>
+          <a:ln/>
+        </p:spPr>
+        <p:txBody>
+          <a:bodyPr wrap="square" lIns="0" tIns="0" rIns="0" bIns="0" rtlCol="0" anchor="t"/>
+          <a:lstStyle/>
+          <a:p>
+            <a:pPr algn="l" indent="0" marL="0">
+              <a:buNone/>
+            </a:pPr>
+            <a:r>
+              <a:rPr lang="en-US" sz="1100" b="1" dirty="0">
+                <a:solidFill>
+                  <a:schemeClr val="tx1"/>
+                </a:solidFill>
+              </a:rPr>
+              <a:t>1</a:t>
+            </a:r>
+            <a:endParaRPr lang="en-US" sz="1100" dirty="0"/>
+          </a:p>
+        </p:txBody>
+      </p:sp>
+      <p:sp>
+        <p:nvSpPr>
+          <p:cNvPr id="20" name="Cardinality N"/>
+          <p:cNvSpPr txBox="1"/>
+          <p:nvPr/>
+        </p:nvSpPr>
+        <p:spPr>
+          <a:xfrm>
+            <a:off x="7068312" y="4530852"/>
+            <a:ext cx="201168" cy="219456"/>
+          </a:xfrm>
+          <a:prstGeom prst="rect">
+            <a:avLst/>
+          </a:prstGeom>
+          <a:noFill/>
+          <a:ln/>
+        </p:spPr>
+        <p:txBody>
+          <a:bodyPr wrap="square" lIns="0" tIns="0" rIns="0" bIns="0" rtlCol="0" anchor="t"/>
+          <a:lstStyle/>
+          <a:p>
+            <a:pPr algn="r" indent="0" marL="0">
+              <a:buNone/>
+            </a:pPr>
+            <a:r>
+              <a:rPr lang="en-US" sz="1100" b="1" dirty="0">
+                <a:solidFill>
+                  <a:schemeClr val="tx1"/>
+                </a:solidFill>
+              </a:rPr>
+              <a:t>N</a:t>
+            </a:r>
+            <a:endParaRPr lang="en-US" sz="1100" dirty="0"/>
+          </a:p>
+        </p:txBody>
+      </p:sp>
+      <p:sp>
+        <p:nvSpPr>
+          <p:cNvPr id="21" name="PHIM body"/>
           <p:cNvSpPr/>
           <p:nvPr/>
         </p:nvSpPr>
         <p:spPr>
           <a:xfrm>
             <a:off x="4389120" y="1682496"/>
-            <a:ext cx="1874520" cy="1563624"/>
+            <a:ext cx="1527048" cy="1289304"/>
           </a:xfrm>
           <a:prstGeom prst="rect">
             <a:avLst/>
@@ -3443,14 +3991,14 @@
       </p:sp>
       <p:sp>
         <p:nvSpPr>
-          <p:cNvPr id="6" name="PHIM header"/>
+          <p:cNvPr id="22" name="PHIM header"/>
           <p:cNvSpPr/>
           <p:nvPr/>
         </p:nvSpPr>
         <p:spPr>
           <a:xfrm>
             <a:off x="4389120" y="1371600"/>
-            <a:ext cx="1874520" cy="310896"/>
+            <a:ext cx="1527048" cy="310896"/>
           </a:xfrm>
           <a:prstGeom prst="rect">
             <a:avLst/>
@@ -3485,14 +4033,14 @@
       </p:sp>
       <p:sp>
         <p:nvSpPr>
-          <p:cNvPr id="7" name="PHIM attributes"/>
+          <p:cNvPr id="23" name="PHIM attributes"/>
           <p:cNvSpPr txBox="1"/>
           <p:nvPr/>
         </p:nvSpPr>
         <p:spPr>
           <a:xfrm>
             <a:off x="4498848" y="1746504"/>
-            <a:ext cx="1655064" cy="1472184"/>
+            <a:ext cx="1307592" cy="1197864"/>
           </a:xfrm>
           <a:prstGeom prst="rect">
             <a:avLst/>
@@ -3592,14 +4140,14 @@
       </p:sp>
       <p:sp>
         <p:nvSpPr>
-          <p:cNvPr id="8" name="SUATCHIEU body"/>
+          <p:cNvPr id="24" name="PHONGCHIEU body"/>
           <p:cNvSpPr/>
           <p:nvPr/>
         </p:nvSpPr>
         <p:spPr>
           <a:xfrm>
-            <a:off x="7114032" y="1682496"/>
-            <a:ext cx="1874520" cy="1563624"/>
+            <a:off x="10204704" y="1682496"/>
+            <a:ext cx="1527048" cy="1289304"/>
           </a:xfrm>
           <a:prstGeom prst="rect">
             <a:avLst/>
@@ -3617,20 +4165,20 @@
       </p:sp>
       <p:sp>
         <p:nvSpPr>
-          <p:cNvPr id="9" name="SUATCHIEU header"/>
+          <p:cNvPr id="25" name="PHONGCHIEU header"/>
           <p:cNvSpPr/>
           <p:nvPr/>
         </p:nvSpPr>
         <p:spPr>
           <a:xfrm>
-            <a:off x="7114032" y="1371600"/>
-            <a:ext cx="1874520" cy="310896"/>
+            <a:off x="10204704" y="1371600"/>
+            <a:ext cx="1527048" cy="310896"/>
           </a:xfrm>
           <a:prstGeom prst="rect">
             <a:avLst/>
           </a:prstGeom>
           <a:solidFill>
-            <a:schemeClr val="accent1"/>
+            <a:schemeClr val="tx1"/>
           </a:solidFill>
           <a:ln w="15875">
             <a:solidFill>
@@ -3648,10 +4196,10 @@
             <a:r>
               <a:rPr lang="en-US" sz="1200" b="1" dirty="0">
                 <a:solidFill>
-                  <a:schemeClr val="tx1"/>
-                </a:solidFill>
-              </a:rPr>
-              <a:t>SUATCHIEU</a:t>
+                  <a:schemeClr val="bg1"/>
+                </a:solidFill>
+              </a:rPr>
+              <a:t>PHONGCHIEU</a:t>
             </a:r>
             <a:endParaRPr lang="en-US" sz="1200" dirty="0"/>
           </a:p>
@@ -3659,14 +4207,14 @@
       </p:sp>
       <p:sp>
         <p:nvSpPr>
-          <p:cNvPr id="10" name="SUATCHIEU attributes"/>
+          <p:cNvPr id="26" name="PHONGCHIEU attributes"/>
           <p:cNvSpPr txBox="1"/>
           <p:nvPr/>
         </p:nvSpPr>
         <p:spPr>
           <a:xfrm>
-            <a:off x="7223760" y="1746504"/>
-            <a:ext cx="1655064" cy="1472184"/>
+            <a:off x="10314432" y="1746504"/>
+            <a:ext cx="1307592" cy="1197864"/>
           </a:xfrm>
           <a:prstGeom prst="rect">
             <a:avLst/>
@@ -3690,7 +4238,7 @@
                   <a:schemeClr val="tx1"/>
                 </a:solidFill>
               </a:rPr>
-              <a:t>MaSuat</a:t>
+              <a:t>MaPhong</a:t>
             </a:r>
             <a:endParaRPr lang="en-US" sz="1050" dirty="0"/>
           </a:p>
@@ -3702,12 +4250,12 @@
               <a:buNone/>
             </a:pPr>
             <a:r>
-              <a:rPr lang="en-US" sz="1050" i="1" dirty="0">
-                <a:solidFill>
-                  <a:schemeClr val="tx2"/>
-                </a:solidFill>
-              </a:rPr>
-              <a:t>MaPhim (FK)</a:t>
+              <a:rPr lang="en-US" sz="1050" dirty="0">
+                <a:solidFill>
+                  <a:schemeClr val="tx1"/>
+                </a:solidFill>
+              </a:rPr>
+              <a:t>TenPhong</a:t>
             </a:r>
             <a:endParaRPr lang="en-US" sz="1050" dirty="0"/>
           </a:p>
@@ -3719,12 +4267,12 @@
               <a:buNone/>
             </a:pPr>
             <a:r>
-              <a:rPr lang="en-US" sz="1050" i="1" dirty="0">
-                <a:solidFill>
-                  <a:schemeClr val="tx2"/>
-                </a:solidFill>
-              </a:rPr>
-              <a:t>MaPhong (FK)</a:t>
+              <a:rPr lang="en-US" sz="1050" dirty="0">
+                <a:solidFill>
+                  <a:schemeClr val="tx1"/>
+                </a:solidFill>
+              </a:rPr>
+              <a:t>LoaiPhong</a:t>
             </a:r>
             <a:endParaRPr lang="en-US" sz="1050" dirty="0"/>
           </a:p>
@@ -3741,41 +4289,7 @@
                   <a:schemeClr val="tx1"/>
                 </a:solidFill>
               </a:rPr>
-              <a:t>NgayChieu</a:t>
-            </a:r>
-            <a:endParaRPr lang="en-US" sz="1050" dirty="0"/>
-          </a:p>
-          <a:p>
-            <a:pPr indent="0" marL="0">
-              <a:lnSpc>
-                <a:spcPts val="1700"/>
-              </a:lnSpc>
-              <a:buNone/>
-            </a:pPr>
-            <a:r>
-              <a:rPr lang="en-US" sz="1050" dirty="0">
-                <a:solidFill>
-                  <a:schemeClr val="tx1"/>
-                </a:solidFill>
-              </a:rPr>
-              <a:t>GioBatDau</a:t>
-            </a:r>
-            <a:endParaRPr lang="en-US" sz="1050" dirty="0"/>
-          </a:p>
-          <a:p>
-            <a:pPr indent="0" marL="0">
-              <a:lnSpc>
-                <a:spcPts val="1700"/>
-              </a:lnSpc>
-              <a:buNone/>
-            </a:pPr>
-            <a:r>
-              <a:rPr lang="en-US" sz="1050" dirty="0">
-                <a:solidFill>
-                  <a:schemeClr val="tx1"/>
-                </a:solidFill>
-              </a:rPr>
-              <a:t>GiaVe</a:t>
+              <a:t>SucChua</a:t>
             </a:r>
             <a:endParaRPr lang="en-US" sz="1050" dirty="0"/>
           </a:p>
@@ -3783,14 +4297,14 @@
       </p:sp>
       <p:sp>
         <p:nvSpPr>
-          <p:cNvPr id="11" name="PHONGCHIEU body"/>
+          <p:cNvPr id="27" name="SUATCHIEU body"/>
           <p:cNvSpPr/>
           <p:nvPr/>
         </p:nvSpPr>
         <p:spPr>
           <a:xfrm>
-            <a:off x="9838944" y="1682496"/>
-            <a:ext cx="1874520" cy="1563624"/>
+            <a:off x="7296912" y="1682496"/>
+            <a:ext cx="1527048" cy="1289304"/>
           </a:xfrm>
           <a:prstGeom prst="rect">
             <a:avLst/>
@@ -3808,20 +4322,20 @@
       </p:sp>
       <p:sp>
         <p:nvSpPr>
-          <p:cNvPr id="12" name="PHONGCHIEU header"/>
+          <p:cNvPr id="28" name="SUATCHIEU header"/>
           <p:cNvSpPr/>
           <p:nvPr/>
         </p:nvSpPr>
         <p:spPr>
           <a:xfrm>
-            <a:off x="9838944" y="1371600"/>
-            <a:ext cx="1874520" cy="310896"/>
+            <a:off x="7296912" y="1371600"/>
+            <a:ext cx="1527048" cy="310896"/>
           </a:xfrm>
           <a:prstGeom prst="rect">
             <a:avLst/>
           </a:prstGeom>
           <a:solidFill>
-            <a:schemeClr val="tx1"/>
+            <a:schemeClr val="accent1"/>
           </a:solidFill>
           <a:ln w="15875">
             <a:solidFill>
@@ -3839,10 +4353,10 @@
             <a:r>
               <a:rPr lang="en-US" sz="1200" b="1" dirty="0">
                 <a:solidFill>
-                  <a:schemeClr val="bg1"/>
-                </a:solidFill>
-              </a:rPr>
-              <a:t>PHONGCHIEU</a:t>
+                  <a:schemeClr val="tx1"/>
+                </a:solidFill>
+              </a:rPr>
+              <a:t>SUATCHIEU</a:t>
             </a:r>
             <a:endParaRPr lang="en-US" sz="1200" dirty="0"/>
           </a:p>
@@ -3850,14 +4364,14 @@
       </p:sp>
       <p:sp>
         <p:nvSpPr>
-          <p:cNvPr id="13" name="PHONGCHIEU attributes"/>
+          <p:cNvPr id="29" name="SUATCHIEU attributes"/>
           <p:cNvSpPr txBox="1"/>
           <p:nvPr/>
         </p:nvSpPr>
         <p:spPr>
           <a:xfrm>
-            <a:off x="9948672" y="1746504"/>
-            <a:ext cx="1655064" cy="1472184"/>
+            <a:off x="7406640" y="1746504"/>
+            <a:ext cx="1307592" cy="1197864"/>
           </a:xfrm>
           <a:prstGeom prst="rect">
             <a:avLst/>
@@ -3881,7 +4395,7 @@
                   <a:schemeClr val="tx1"/>
                 </a:solidFill>
               </a:rPr>
-              <a:t>MaPhong</a:t>
+              <a:t>MaSuat</a:t>
             </a:r>
             <a:endParaRPr lang="en-US" sz="1050" dirty="0"/>
           </a:p>
@@ -3898,7 +4412,7 @@
                   <a:schemeClr val="tx1"/>
                 </a:solidFill>
               </a:rPr>
-              <a:t>TenPhong</a:t>
+              <a:t>NgayChieu</a:t>
             </a:r>
             <a:endParaRPr lang="en-US" sz="1050" dirty="0"/>
           </a:p>
@@ -3915,7 +4429,7 @@
                   <a:schemeClr val="tx1"/>
                 </a:solidFill>
               </a:rPr>
-              <a:t>LoaiPhong</a:t>
+              <a:t>GioBatDau</a:t>
             </a:r>
             <a:endParaRPr lang="en-US" sz="1050" dirty="0"/>
           </a:p>
@@ -3932,7 +4446,7 @@
                   <a:schemeClr val="tx1"/>
                 </a:solidFill>
               </a:rPr>
-              <a:t>SoGhe</a:t>
+              <a:t>GiaVe</a:t>
             </a:r>
             <a:endParaRPr lang="en-US" sz="1050" dirty="0"/>
           </a:p>
@@ -3940,14 +4454,14 @@
       </p:sp>
       <p:sp>
         <p:nvSpPr>
-          <p:cNvPr id="14" name="KHACHHANG body"/>
+          <p:cNvPr id="30" name="KHACHHANG body"/>
           <p:cNvSpPr/>
           <p:nvPr/>
         </p:nvSpPr>
         <p:spPr>
           <a:xfrm>
-            <a:off x="4389120" y="4334256"/>
-            <a:ext cx="1874520" cy="1289304"/>
+            <a:off x="4389120" y="4379976"/>
+            <a:ext cx="1527048" cy="1106424"/>
           </a:xfrm>
           <a:prstGeom prst="rect">
             <a:avLst/>
@@ -3965,14 +4479,14 @@
       </p:sp>
       <p:sp>
         <p:nvSpPr>
-          <p:cNvPr id="15" name="KHACHHANG header"/>
+          <p:cNvPr id="31" name="KHACHHANG header"/>
           <p:cNvSpPr/>
           <p:nvPr/>
         </p:nvSpPr>
         <p:spPr>
           <a:xfrm>
-            <a:off x="4389120" y="4023360"/>
-            <a:ext cx="1874520" cy="310896"/>
+            <a:off x="4389120" y="4069080"/>
+            <a:ext cx="1527048" cy="310896"/>
           </a:xfrm>
           <a:prstGeom prst="rect">
             <a:avLst/>
@@ -4007,14 +4521,14 @@
       </p:sp>
       <p:sp>
         <p:nvSpPr>
-          <p:cNvPr id="16" name="KHACHHANG attributes"/>
+          <p:cNvPr id="32" name="KHACHHANG attributes"/>
           <p:cNvSpPr txBox="1"/>
           <p:nvPr/>
         </p:nvSpPr>
         <p:spPr>
           <a:xfrm>
-            <a:off x="4498848" y="4398264"/>
-            <a:ext cx="1655064" cy="1197864"/>
+            <a:off x="4498848" y="4443984"/>
+            <a:ext cx="1307592" cy="1014984"/>
           </a:xfrm>
           <a:prstGeom prst="rect">
             <a:avLst/>
@@ -4097,14 +4611,14 @@
       </p:sp>
       <p:sp>
         <p:nvSpPr>
-          <p:cNvPr id="17" name="VE body"/>
+          <p:cNvPr id="33" name="VE body"/>
           <p:cNvSpPr/>
           <p:nvPr/>
         </p:nvSpPr>
         <p:spPr>
           <a:xfrm>
-            <a:off x="7114032" y="4334256"/>
-            <a:ext cx="1874520" cy="1289304"/>
+            <a:off x="7296912" y="4379976"/>
+            <a:ext cx="1527048" cy="1106424"/>
           </a:xfrm>
           <a:prstGeom prst="rect">
             <a:avLst/>
@@ -4122,14 +4636,14 @@
       </p:sp>
       <p:sp>
         <p:nvSpPr>
-          <p:cNvPr id="18" name="VE header"/>
+          <p:cNvPr id="34" name="VE header"/>
           <p:cNvSpPr/>
           <p:nvPr/>
         </p:nvSpPr>
         <p:spPr>
           <a:xfrm>
-            <a:off x="7114032" y="4023360"/>
-            <a:ext cx="1874520" cy="310896"/>
+            <a:off x="7296912" y="4069080"/>
+            <a:ext cx="1527048" cy="310896"/>
           </a:xfrm>
           <a:prstGeom prst="rect">
             <a:avLst/>
@@ -4164,14 +4678,14 @@
       </p:sp>
       <p:sp>
         <p:nvSpPr>
-          <p:cNvPr id="19" name="VE attributes"/>
+          <p:cNvPr id="35" name="VE attributes"/>
           <p:cNvSpPr txBox="1"/>
           <p:nvPr/>
         </p:nvSpPr>
         <p:spPr>
           <a:xfrm>
-            <a:off x="7223760" y="4398264"/>
-            <a:ext cx="1655064" cy="1197864"/>
+            <a:off x="7406640" y="4443984"/>
+            <a:ext cx="1307592" cy="1014984"/>
           </a:xfrm>
           <a:prstGeom prst="rect">
             <a:avLst/>
@@ -4207,12 +4721,12 @@
               <a:buNone/>
             </a:pPr>
             <a:r>
-              <a:rPr lang="en-US" sz="1050" i="1" dirty="0">
-                <a:solidFill>
-                  <a:schemeClr val="tx2"/>
-                </a:solidFill>
-              </a:rPr>
-              <a:t>MaSuat (FK)</a:t>
+              <a:rPr lang="en-US" sz="1050" dirty="0">
+                <a:solidFill>
+                  <a:schemeClr val="tx1"/>
+                </a:solidFill>
+              </a:rPr>
+              <a:t>SoGhe</a:t>
             </a:r>
             <a:endParaRPr lang="en-US" sz="1050" dirty="0"/>
           </a:p>
@@ -4224,570 +4738,12 @@
               <a:buNone/>
             </a:pPr>
             <a:r>
-              <a:rPr lang="en-US" sz="1050" i="1" dirty="0">
-                <a:solidFill>
-                  <a:schemeClr val="tx2"/>
-                </a:solidFill>
-              </a:rPr>
-              <a:t>MaKH (FK)</a:t>
-            </a:r>
-            <a:endParaRPr lang="en-US" sz="1050" dirty="0"/>
-          </a:p>
-          <a:p>
-            <a:pPr indent="0" marL="0">
-              <a:lnSpc>
-                <a:spcPts val="1700"/>
-              </a:lnSpc>
-              <a:buNone/>
-            </a:pPr>
-            <a:r>
               <a:rPr lang="en-US" sz="1050" dirty="0">
                 <a:solidFill>
                   <a:schemeClr val="tx1"/>
                 </a:solidFill>
               </a:rPr>
-              <a:t>SoGhe</a:t>
-            </a:r>
-            <a:endParaRPr lang="en-US" sz="1050" dirty="0"/>
-          </a:p>
-          <a:p>
-            <a:pPr indent="0" marL="0">
-              <a:lnSpc>
-                <a:spcPts val="1700"/>
-              </a:lnSpc>
-              <a:buNone/>
-            </a:pPr>
-            <a:r>
-              <a:rPr lang="en-US" sz="1050" dirty="0">
-                <a:solidFill>
-                  <a:schemeClr val="tx1"/>
-                </a:solidFill>
-              </a:rPr>
               <a:t>NgayDat</a:t>
-            </a:r>
-            <a:endParaRPr lang="en-US" sz="1050" dirty="0"/>
-          </a:p>
-        </p:txBody>
-      </p:sp>
-      <p:sp>
-        <p:nvSpPr>
-          <p:cNvPr id="20" name="Line PHIM-SUATCHIEU"/>
-          <p:cNvSpPr/>
-          <p:nvPr/>
-        </p:nvSpPr>
-        <p:spPr>
-          <a:xfrm>
-            <a:off x="6263640" y="2308860"/>
-            <a:ext cx="850392" cy="0"/>
-          </a:xfrm>
-          <a:prstGeom prst="line">
-            <a:avLst/>
-          </a:prstGeom>
-          <a:noFill/>
-          <a:ln w="22225">
-            <a:solidFill>
-              <a:schemeClr val="tx1"/>
-            </a:solidFill>
-            <a:prstDash val="solid"/>
-          </a:ln>
-        </p:spPr>
-      </p:sp>
-      <p:sp>
-        <p:nvSpPr>
-          <p:cNvPr id="21" name="Relationship được chiếu"/>
-          <p:cNvSpPr txBox="1"/>
-          <p:nvPr/>
-        </p:nvSpPr>
-        <p:spPr>
-          <a:xfrm>
-            <a:off x="6263640" y="2034540"/>
-            <a:ext cx="850392" cy="219456"/>
-          </a:xfrm>
-          <a:prstGeom prst="rect">
-            <a:avLst/>
-          </a:prstGeom>
-          <a:noFill/>
-          <a:ln/>
-        </p:spPr>
-        <p:txBody>
-          <a:bodyPr wrap="square" lIns="0" tIns="0" rIns="0" bIns="0" rtlCol="0" anchor="t"/>
-          <a:lstStyle/>
-          <a:p>
-            <a:pPr algn="ctr" indent="0" marL="0">
-              <a:buNone/>
-            </a:pPr>
-            <a:r>
-              <a:rPr lang="en-US" sz="1050" i="1" dirty="0">
-                <a:solidFill>
-                  <a:schemeClr val="tx2"/>
-                </a:solidFill>
-              </a:rPr>
-              <a:t>được chiếu</a:t>
-            </a:r>
-            <a:endParaRPr lang="en-US" sz="1050" dirty="0"/>
-          </a:p>
-        </p:txBody>
-      </p:sp>
-      <p:sp>
-        <p:nvSpPr>
-          <p:cNvPr id="22" name="Cardinality 1"/>
-          <p:cNvSpPr txBox="1"/>
-          <p:nvPr/>
-        </p:nvSpPr>
-        <p:spPr>
-          <a:xfrm>
-            <a:off x="6309360" y="2345436"/>
-            <a:ext cx="274320" cy="219456"/>
-          </a:xfrm>
-          <a:prstGeom prst="rect">
-            <a:avLst/>
-          </a:prstGeom>
-          <a:noFill/>
-          <a:ln/>
-        </p:spPr>
-        <p:txBody>
-          <a:bodyPr wrap="square" lIns="0" tIns="0" rIns="0" bIns="0" rtlCol="0" anchor="t"/>
-          <a:lstStyle/>
-          <a:p>
-            <a:pPr indent="0" marL="0">
-              <a:buNone/>
-            </a:pPr>
-            <a:r>
-              <a:rPr lang="en-US" sz="1050" b="1" dirty="0">
-                <a:solidFill>
-                  <a:schemeClr val="tx1"/>
-                </a:solidFill>
-              </a:rPr>
-              <a:t>1</a:t>
-            </a:r>
-            <a:endParaRPr lang="en-US" sz="1050" dirty="0"/>
-          </a:p>
-        </p:txBody>
-      </p:sp>
-      <p:sp>
-        <p:nvSpPr>
-          <p:cNvPr id="23" name="Cardinality N"/>
-          <p:cNvSpPr txBox="1"/>
-          <p:nvPr/>
-        </p:nvSpPr>
-        <p:spPr>
-          <a:xfrm>
-            <a:off x="6793992" y="2345436"/>
-            <a:ext cx="274320" cy="219456"/>
-          </a:xfrm>
-          <a:prstGeom prst="rect">
-            <a:avLst/>
-          </a:prstGeom>
-          <a:noFill/>
-          <a:ln/>
-        </p:spPr>
-        <p:txBody>
-          <a:bodyPr wrap="square" lIns="0" tIns="0" rIns="0" bIns="0" rtlCol="0" anchor="t"/>
-          <a:lstStyle/>
-          <a:p>
-            <a:pPr algn="r" indent="0" marL="0">
-              <a:buNone/>
-            </a:pPr>
-            <a:r>
-              <a:rPr lang="en-US" sz="1050" b="1" dirty="0">
-                <a:solidFill>
-                  <a:schemeClr val="tx1"/>
-                </a:solidFill>
-              </a:rPr>
-              <a:t>N</a:t>
-            </a:r>
-            <a:endParaRPr lang="en-US" sz="1050" dirty="0"/>
-          </a:p>
-        </p:txBody>
-      </p:sp>
-      <p:sp>
-        <p:nvSpPr>
-          <p:cNvPr id="24" name="Line SUATCHIEU-PHONGCHIEU"/>
-          <p:cNvSpPr/>
-          <p:nvPr/>
-        </p:nvSpPr>
-        <p:spPr>
-          <a:xfrm>
-            <a:off x="8988552" y="2308860"/>
-            <a:ext cx="850392" cy="0"/>
-          </a:xfrm>
-          <a:prstGeom prst="line">
-            <a:avLst/>
-          </a:prstGeom>
-          <a:noFill/>
-          <a:ln w="22225">
-            <a:solidFill>
-              <a:schemeClr val="tx1"/>
-            </a:solidFill>
-            <a:prstDash val="solid"/>
-          </a:ln>
-        </p:spPr>
-      </p:sp>
-      <p:sp>
-        <p:nvSpPr>
-          <p:cNvPr id="25" name="Relationship diễn ra tại"/>
-          <p:cNvSpPr txBox="1"/>
-          <p:nvPr/>
-        </p:nvSpPr>
-        <p:spPr>
-          <a:xfrm>
-            <a:off x="8988552" y="2034540"/>
-            <a:ext cx="850392" cy="219456"/>
-          </a:xfrm>
-          <a:prstGeom prst="rect">
-            <a:avLst/>
-          </a:prstGeom>
-          <a:noFill/>
-          <a:ln/>
-        </p:spPr>
-        <p:txBody>
-          <a:bodyPr wrap="square" lIns="0" tIns="0" rIns="0" bIns="0" rtlCol="0" anchor="t"/>
-          <a:lstStyle/>
-          <a:p>
-            <a:pPr algn="ctr" indent="0" marL="0">
-              <a:buNone/>
-            </a:pPr>
-            <a:r>
-              <a:rPr lang="en-US" sz="1050" i="1" dirty="0">
-                <a:solidFill>
-                  <a:schemeClr val="tx2"/>
-                </a:solidFill>
-              </a:rPr>
-              <a:t>diễn ra tại</a:t>
-            </a:r>
-            <a:endParaRPr lang="en-US" sz="1050" dirty="0"/>
-          </a:p>
-        </p:txBody>
-      </p:sp>
-      <p:sp>
-        <p:nvSpPr>
-          <p:cNvPr id="26" name="Cardinality N"/>
-          <p:cNvSpPr txBox="1"/>
-          <p:nvPr/>
-        </p:nvSpPr>
-        <p:spPr>
-          <a:xfrm>
-            <a:off x="9034272" y="2345436"/>
-            <a:ext cx="274320" cy="219456"/>
-          </a:xfrm>
-          <a:prstGeom prst="rect">
-            <a:avLst/>
-          </a:prstGeom>
-          <a:noFill/>
-          <a:ln/>
-        </p:spPr>
-        <p:txBody>
-          <a:bodyPr wrap="square" lIns="0" tIns="0" rIns="0" bIns="0" rtlCol="0" anchor="t"/>
-          <a:lstStyle/>
-          <a:p>
-            <a:pPr indent="0" marL="0">
-              <a:buNone/>
-            </a:pPr>
-            <a:r>
-              <a:rPr lang="en-US" sz="1050" b="1" dirty="0">
-                <a:solidFill>
-                  <a:schemeClr val="tx1"/>
-                </a:solidFill>
-              </a:rPr>
-              <a:t>N</a:t>
-            </a:r>
-            <a:endParaRPr lang="en-US" sz="1050" dirty="0"/>
-          </a:p>
-        </p:txBody>
-      </p:sp>
-      <p:sp>
-        <p:nvSpPr>
-          <p:cNvPr id="27" name="Cardinality 1"/>
-          <p:cNvSpPr txBox="1"/>
-          <p:nvPr/>
-        </p:nvSpPr>
-        <p:spPr>
-          <a:xfrm>
-            <a:off x="9518904" y="2345436"/>
-            <a:ext cx="274320" cy="219456"/>
-          </a:xfrm>
-          <a:prstGeom prst="rect">
-            <a:avLst/>
-          </a:prstGeom>
-          <a:noFill/>
-          <a:ln/>
-        </p:spPr>
-        <p:txBody>
-          <a:bodyPr wrap="square" lIns="0" tIns="0" rIns="0" bIns="0" rtlCol="0" anchor="t"/>
-          <a:lstStyle/>
-          <a:p>
-            <a:pPr algn="r" indent="0" marL="0">
-              <a:buNone/>
-            </a:pPr>
-            <a:r>
-              <a:rPr lang="en-US" sz="1050" b="1" dirty="0">
-                <a:solidFill>
-                  <a:schemeClr val="tx1"/>
-                </a:solidFill>
-              </a:rPr>
-              <a:t>1</a:t>
-            </a:r>
-            <a:endParaRPr lang="en-US" sz="1050" dirty="0"/>
-          </a:p>
-        </p:txBody>
-      </p:sp>
-      <p:sp>
-        <p:nvSpPr>
-          <p:cNvPr id="28" name="Line SUATCHIEU-VE"/>
-          <p:cNvSpPr/>
-          <p:nvPr/>
-        </p:nvSpPr>
-        <p:spPr>
-          <a:xfrm>
-            <a:off x="8051292" y="3246120"/>
-            <a:ext cx="0" cy="777240"/>
-          </a:xfrm>
-          <a:prstGeom prst="line">
-            <a:avLst/>
-          </a:prstGeom>
-          <a:noFill/>
-          <a:ln w="22225">
-            <a:solidFill>
-              <a:schemeClr val="tx1"/>
-            </a:solidFill>
-            <a:prstDash val="solid"/>
-          </a:ln>
-        </p:spPr>
-      </p:sp>
-      <p:sp>
-        <p:nvSpPr>
-          <p:cNvPr id="29" name="Cardinality 1"/>
-          <p:cNvSpPr txBox="1"/>
-          <p:nvPr/>
-        </p:nvSpPr>
-        <p:spPr>
-          <a:xfrm>
-            <a:off x="7731252" y="3273552"/>
-            <a:ext cx="274320" cy="219456"/>
-          </a:xfrm>
-          <a:prstGeom prst="rect">
-            <a:avLst/>
-          </a:prstGeom>
-          <a:noFill/>
-          <a:ln/>
-        </p:spPr>
-        <p:txBody>
-          <a:bodyPr wrap="square" lIns="0" tIns="0" rIns="0" bIns="0" rtlCol="0" anchor="t"/>
-          <a:lstStyle/>
-          <a:p>
-            <a:pPr algn="r" indent="0" marL="0">
-              <a:buNone/>
-            </a:pPr>
-            <a:r>
-              <a:rPr lang="en-US" sz="1050" b="1" dirty="0">
-                <a:solidFill>
-                  <a:schemeClr val="tx1"/>
-                </a:solidFill>
-              </a:rPr>
-              <a:t>1</a:t>
-            </a:r>
-            <a:endParaRPr lang="en-US" sz="1050" dirty="0"/>
-          </a:p>
-        </p:txBody>
-      </p:sp>
-      <p:sp>
-        <p:nvSpPr>
-          <p:cNvPr id="30" name="Cardinality N"/>
-          <p:cNvSpPr txBox="1"/>
-          <p:nvPr/>
-        </p:nvSpPr>
-        <p:spPr>
-          <a:xfrm>
-            <a:off x="7731252" y="3776472"/>
-            <a:ext cx="274320" cy="219456"/>
-          </a:xfrm>
-          <a:prstGeom prst="rect">
-            <a:avLst/>
-          </a:prstGeom>
-          <a:noFill/>
-          <a:ln/>
-        </p:spPr>
-        <p:txBody>
-          <a:bodyPr wrap="square" lIns="0" tIns="0" rIns="0" bIns="0" rtlCol="0" anchor="t"/>
-          <a:lstStyle/>
-          <a:p>
-            <a:pPr algn="r" indent="0" marL="0">
-              <a:buNone/>
-            </a:pPr>
-            <a:r>
-              <a:rPr lang="en-US" sz="1050" b="1" dirty="0">
-                <a:solidFill>
-                  <a:schemeClr val="tx1"/>
-                </a:solidFill>
-              </a:rPr>
-              <a:t>N</a:t>
-            </a:r>
-            <a:endParaRPr lang="en-US" sz="1050" dirty="0"/>
-          </a:p>
-        </p:txBody>
-      </p:sp>
-      <p:sp>
-        <p:nvSpPr>
-          <p:cNvPr id="31" name="Relationship có vé"/>
-          <p:cNvSpPr txBox="1"/>
-          <p:nvPr/>
-        </p:nvSpPr>
-        <p:spPr>
-          <a:xfrm>
-            <a:off x="8161020" y="3525012"/>
-            <a:ext cx="822960" cy="219456"/>
-          </a:xfrm>
-          <a:prstGeom prst="rect">
-            <a:avLst/>
-          </a:prstGeom>
-          <a:noFill/>
-          <a:ln/>
-        </p:spPr>
-        <p:txBody>
-          <a:bodyPr wrap="square" lIns="0" tIns="0" rIns="0" bIns="0" rtlCol="0" anchor="t"/>
-          <a:lstStyle/>
-          <a:p>
-            <a:pPr algn="l" indent="0" marL="0">
-              <a:buNone/>
-            </a:pPr>
-            <a:r>
-              <a:rPr lang="en-US" sz="1050" i="1" dirty="0">
-                <a:solidFill>
-                  <a:schemeClr val="tx2"/>
-                </a:solidFill>
-              </a:rPr>
-              <a:t>có vé</a:t>
-            </a:r>
-            <a:endParaRPr lang="en-US" sz="1050" dirty="0"/>
-          </a:p>
-        </p:txBody>
-      </p:sp>
-      <p:sp>
-        <p:nvSpPr>
-          <p:cNvPr id="32" name="Line KHACHHANG-VE"/>
-          <p:cNvSpPr/>
-          <p:nvPr/>
-        </p:nvSpPr>
-        <p:spPr>
-          <a:xfrm>
-            <a:off x="6263640" y="4823460"/>
-            <a:ext cx="850392" cy="0"/>
-          </a:xfrm>
-          <a:prstGeom prst="line">
-            <a:avLst/>
-          </a:prstGeom>
-          <a:noFill/>
-          <a:ln w="22225">
-            <a:solidFill>
-              <a:schemeClr val="tx1"/>
-            </a:solidFill>
-            <a:prstDash val="solid"/>
-          </a:ln>
-        </p:spPr>
-      </p:sp>
-      <p:sp>
-        <p:nvSpPr>
-          <p:cNvPr id="33" name="Relationship đặt"/>
-          <p:cNvSpPr txBox="1"/>
-          <p:nvPr/>
-        </p:nvSpPr>
-        <p:spPr>
-          <a:xfrm>
-            <a:off x="6263640" y="4549140"/>
-            <a:ext cx="850392" cy="219456"/>
-          </a:xfrm>
-          <a:prstGeom prst="rect">
-            <a:avLst/>
-          </a:prstGeom>
-          <a:noFill/>
-          <a:ln/>
-        </p:spPr>
-        <p:txBody>
-          <a:bodyPr wrap="square" lIns="0" tIns="0" rIns="0" bIns="0" rtlCol="0" anchor="t"/>
-          <a:lstStyle/>
-          <a:p>
-            <a:pPr algn="ctr" indent="0" marL="0">
-              <a:buNone/>
-            </a:pPr>
-            <a:r>
-              <a:rPr lang="en-US" sz="1050" i="1" dirty="0">
-                <a:solidFill>
-                  <a:schemeClr val="tx2"/>
-                </a:solidFill>
-              </a:rPr>
-              <a:t>đặt</a:t>
-            </a:r>
-            <a:endParaRPr lang="en-US" sz="1050" dirty="0"/>
-          </a:p>
-        </p:txBody>
-      </p:sp>
-      <p:sp>
-        <p:nvSpPr>
-          <p:cNvPr id="34" name="Cardinality 1"/>
-          <p:cNvSpPr txBox="1"/>
-          <p:nvPr/>
-        </p:nvSpPr>
-        <p:spPr>
-          <a:xfrm>
-            <a:off x="6309360" y="4860036"/>
-            <a:ext cx="274320" cy="219456"/>
-          </a:xfrm>
-          <a:prstGeom prst="rect">
-            <a:avLst/>
-          </a:prstGeom>
-          <a:noFill/>
-          <a:ln/>
-        </p:spPr>
-        <p:txBody>
-          <a:bodyPr wrap="square" lIns="0" tIns="0" rIns="0" bIns="0" rtlCol="0" anchor="t"/>
-          <a:lstStyle/>
-          <a:p>
-            <a:pPr indent="0" marL="0">
-              <a:buNone/>
-            </a:pPr>
-            <a:r>
-              <a:rPr lang="en-US" sz="1050" b="1" dirty="0">
-                <a:solidFill>
-                  <a:schemeClr val="tx1"/>
-                </a:solidFill>
-              </a:rPr>
-              <a:t>1</a:t>
-            </a:r>
-            <a:endParaRPr lang="en-US" sz="1050" dirty="0"/>
-          </a:p>
-        </p:txBody>
-      </p:sp>
-      <p:sp>
-        <p:nvSpPr>
-          <p:cNvPr id="35" name="Cardinality N"/>
-          <p:cNvSpPr txBox="1"/>
-          <p:nvPr/>
-        </p:nvSpPr>
-        <p:spPr>
-          <a:xfrm>
-            <a:off x="6793992" y="4860036"/>
-            <a:ext cx="274320" cy="219456"/>
-          </a:xfrm>
-          <a:prstGeom prst="rect">
-            <a:avLst/>
-          </a:prstGeom>
-          <a:noFill/>
-          <a:ln/>
-        </p:spPr>
-        <p:txBody>
-          <a:bodyPr wrap="square" lIns="0" tIns="0" rIns="0" bIns="0" rtlCol="0" anchor="t"/>
-          <a:lstStyle/>
-          <a:p>
-            <a:pPr algn="r" indent="0" marL="0">
-              <a:buNone/>
-            </a:pPr>
-            <a:r>
-              <a:rPr lang="en-US" sz="1050" b="1" dirty="0">
-                <a:solidFill>
-                  <a:schemeClr val="tx1"/>
-                </a:solidFill>
-              </a:rPr>
-              <a:t>N</a:t>
             </a:r>
             <a:endParaRPr lang="en-US" sz="1050" dirty="0"/>
           </a:p>
@@ -4801,12 +4757,12 @@
         </p:nvSpPr>
         <p:spPr>
           <a:xfrm>
-            <a:off x="9838944" y="4023360"/>
-            <a:ext cx="1874520" cy="1600200"/>
+            <a:off x="9144000" y="4069080"/>
+            <a:ext cx="2587752" cy="1417320"/>
           </a:xfrm>
           <a:prstGeom prst="roundRect">
             <a:avLst>
-              <a:gd name="adj" fmla="val 4571"/>
+              <a:gd name="adj" fmla="val 5161"/>
             </a:avLst>
           </a:prstGeom>
           <a:solidFill>
@@ -4828,7 +4784,7 @@
         </p:nvSpPr>
         <p:spPr>
           <a:xfrm>
-            <a:off x="9976104" y="4114800"/>
+            <a:off x="9281160" y="4160520"/>
             <a:ext cx="1645920" cy="237744"/>
           </a:xfrm>
           <a:prstGeom prst="rect">
@@ -4864,8 +4820,8 @@
         </p:nvSpPr>
         <p:spPr>
           <a:xfrm>
-            <a:off x="9976104" y="4434840"/>
-            <a:ext cx="731520" cy="219456"/>
+            <a:off x="9281160" y="4434840"/>
+            <a:ext cx="640080" cy="219456"/>
           </a:xfrm>
           <a:prstGeom prst="rect">
             <a:avLst/>
@@ -4900,8 +4856,8 @@
         </p:nvSpPr>
         <p:spPr>
           <a:xfrm>
-            <a:off x="10707624" y="4434840"/>
-            <a:ext cx="914400" cy="219456"/>
+            <a:off x="10012680" y="4434840"/>
+            <a:ext cx="1627632" cy="219456"/>
           </a:xfrm>
           <a:prstGeom prst="rect">
             <a:avLst/>
@@ -4930,14 +4886,39 @@
       </p:sp>
       <p:sp>
         <p:nvSpPr>
-          <p:cNvPr id="40" name="Legend FK sample"/>
+          <p:cNvPr id="40" name="Legend relationship swatch"/>
+          <p:cNvSpPr/>
+          <p:nvPr/>
+        </p:nvSpPr>
+        <p:spPr>
+          <a:xfrm>
+            <a:off x="9281160" y="4681728"/>
+            <a:ext cx="384048" cy="237744"/>
+          </a:xfrm>
+          <a:prstGeom prst="diamond">
+            <a:avLst/>
+          </a:prstGeom>
+          <a:solidFill>
+            <a:schemeClr val="bg1"/>
+          </a:solidFill>
+          <a:ln w="12700">
+            <a:solidFill>
+              <a:schemeClr val="tx1"/>
+            </a:solidFill>
+            <a:prstDash val="solid"/>
+          </a:ln>
+        </p:spPr>
+      </p:sp>
+      <p:sp>
+        <p:nvSpPr>
+          <p:cNvPr id="41" name="Legend relationship text"/>
           <p:cNvSpPr txBox="1"/>
           <p:nvPr/>
         </p:nvSpPr>
         <p:spPr>
           <a:xfrm>
-            <a:off x="9976104" y="4736592"/>
-            <a:ext cx="731520" cy="219456"/>
+            <a:off x="10012680" y="4690872"/>
+            <a:ext cx="1627632" cy="219456"/>
           </a:xfrm>
           <a:prstGeom prst="rect">
             <a:avLst/>
@@ -4953,12 +4934,12 @@
               <a:buNone/>
             </a:pPr>
             <a:r>
-              <a:rPr lang="en-US" sz="1050" i="1" dirty="0">
-                <a:solidFill>
-                  <a:schemeClr val="tx2"/>
-                </a:solidFill>
-              </a:rPr>
-              <a:t>MaXX</a:t>
+              <a:rPr lang="en-US" sz="1050" dirty="0">
+                <a:solidFill>
+                  <a:schemeClr val="tx1"/>
+                </a:solidFill>
+              </a:rPr>
+              <a:t>Quan hệ</a:t>
             </a:r>
             <a:endParaRPr lang="en-US" sz="1050" dirty="0"/>
           </a:p>
@@ -4966,50 +4947,14 @@
       </p:sp>
       <p:sp>
         <p:nvSpPr>
-          <p:cNvPr id="41" name="Legend FK text"/>
-          <p:cNvSpPr txBox="1"/>
-          <p:nvPr/>
-        </p:nvSpPr>
-        <p:spPr>
-          <a:xfrm>
-            <a:off x="10707624" y="4736592"/>
-            <a:ext cx="914400" cy="219456"/>
-          </a:xfrm>
-          <a:prstGeom prst="rect">
-            <a:avLst/>
-          </a:prstGeom>
-          <a:noFill/>
-          <a:ln/>
-        </p:spPr>
-        <p:txBody>
-          <a:bodyPr wrap="square" lIns="0" tIns="0" rIns="0" bIns="0" rtlCol="0" anchor="t"/>
-          <a:lstStyle/>
-          <a:p>
-            <a:pPr indent="0" marL="0">
-              <a:buNone/>
-            </a:pPr>
-            <a:r>
-              <a:rPr lang="en-US" sz="1050" dirty="0">
-                <a:solidFill>
-                  <a:schemeClr val="tx1"/>
-                </a:solidFill>
-              </a:rPr>
-              <a:t>Khóa ngoại</a:t>
-            </a:r>
-            <a:endParaRPr lang="en-US" sz="1050" dirty="0"/>
-          </a:p>
-        </p:txBody>
-      </p:sp>
-      <p:sp>
-        <p:nvSpPr>
-          <p:cNvPr id="42" name="Legend junction swatch"/>
+          <p:cNvPr id="42" name="Legend associative swatch"/>
           <p:cNvSpPr/>
           <p:nvPr/>
         </p:nvSpPr>
         <p:spPr>
           <a:xfrm>
-            <a:off x="9976104" y="5065776"/>
-            <a:ext cx="502920" cy="182880"/>
+            <a:off x="9281160" y="4965192"/>
+            <a:ext cx="384048" cy="182880"/>
           </a:xfrm>
           <a:prstGeom prst="rect">
             <a:avLst/>
@@ -5027,14 +4972,14 @@
       </p:sp>
       <p:sp>
         <p:nvSpPr>
-          <p:cNvPr id="43" name="Legend junction text"/>
+          <p:cNvPr id="43" name="Legend associative text"/>
           <p:cNvSpPr txBox="1"/>
           <p:nvPr/>
         </p:nvSpPr>
         <p:spPr>
           <a:xfrm>
-            <a:off x="10707624" y="5047488"/>
-            <a:ext cx="960120" cy="219456"/>
+            <a:off x="10012680" y="4946904"/>
+            <a:ext cx="1627632" cy="219456"/>
           </a:xfrm>
           <a:prstGeom prst="rect">
             <a:avLst/>
@@ -5055,7 +5000,7 @@
                   <a:schemeClr val="tx1"/>
                 </a:solidFill>
               </a:rPr>
-              <a:t>Bảng liên kết</a:t>
+              <a:t>Thực thể kết hợp</a:t>
             </a:r>
             <a:endParaRPr lang="en-US" sz="1050" dirty="0"/>
           </a:p>
@@ -5069,8 +5014,8 @@
         </p:nvSpPr>
         <p:spPr>
           <a:xfrm>
-            <a:off x="9976104" y="5321808"/>
-            <a:ext cx="731520" cy="219456"/>
+            <a:off x="9281160" y="5202936"/>
+            <a:ext cx="640080" cy="219456"/>
           </a:xfrm>
           <a:prstGeom prst="rect">
             <a:avLst/>
@@ -5105,8 +5050,8 @@
         </p:nvSpPr>
         <p:spPr>
           <a:xfrm>
-            <a:off x="10707624" y="5321808"/>
-            <a:ext cx="960120" cy="219456"/>
+            <a:off x="10012680" y="5202936"/>
+            <a:ext cx="1627632" cy="219456"/>
           </a:xfrm>
           <a:prstGeom prst="rect">
             <a:avLst/>
@@ -5141,12 +5086,12 @@
         </p:nvSpPr>
         <p:spPr>
           <a:xfrm>
-            <a:off x="4389120" y="5760720"/>
-            <a:ext cx="7324344" cy="548640"/>
+            <a:off x="4389120" y="5669280"/>
+            <a:ext cx="7342632" cy="640080"/>
           </a:xfrm>
           <a:prstGeom prst="roundRect">
             <a:avLst>
-              <a:gd name="adj" fmla="val 13333"/>
+              <a:gd name="adj" fmla="val 11429"/>
             </a:avLst>
           </a:prstGeom>
           <a:solidFill>
@@ -5168,8 +5113,8 @@
         </p:nvSpPr>
         <p:spPr>
           <a:xfrm>
-            <a:off x="4526280" y="5760720"/>
-            <a:ext cx="7050024" cy="548640"/>
+            <a:off x="4526280" y="5669280"/>
+            <a:ext cx="7068312" cy="640080"/>
           </a:xfrm>
           <a:prstGeom prst="rect">
             <a:avLst/>
@@ -5190,7 +5135,7 @@
                   <a:schemeClr val="tx1"/>
                 </a:solidFill>
               </a:rPr>
-              <a:t>Quan hệ N – N </a:t>
+              <a:t>Quan hệ N – N: </a:t>
             </a:r>
             <a:pPr indent="0" marL="0">
               <a:buNone/>
@@ -5201,7 +5146,7 @@
                   <a:schemeClr val="tx1"/>
                 </a:solidFill>
               </a:rPr>
-              <a:t>được tách thành hai quan hệ 1 – N qua bảng liên kết: KHACHHANG – SUATCHIEU qua bảng VE; PHIM – PHONGCHIEU qua bảng SUATCHIEU.</a:t>
+              <a:t>KHACHHANG – SUATCHIEU (qua thực thể kết hợp VE) và PHIM – PHONGCHIEU (qua SUATCHIEU). Khi chuyển sang lược đồ quan hệ, quan hệ 1 – N trở thành khóa ngoại ở phía N (slide 4).</a:t>
             </a:r>
             <a:endParaRPr lang="en-US" sz="1200" dirty="0"/>
           </a:p>
@@ -5730,7 +5675,7 @@
                   <a:schemeClr val="tx1"/>
                 </a:solidFill>
               </a:rPr>
-              <a:t>SoGhe</a:t>
+              <a:t>SucChua</a:t>
             </a:r>
             <a:pPr indent="0" marL="0">
               <a:lnSpc>
@@ -6443,7 +6388,7 @@
                   <a:schemeClr val="tx1"/>
                 </a:solidFill>
               </a:rPr>
-              <a:t>ThoiLuong &gt; 0;  SoGhe &gt; 0;  GiaVe ≥ 0</a:t>
+              <a:t>ThoiLuong &gt; 0;  SucChua &gt; 0;  GiaVe ≥ 0</a:t>
             </a:r>
             <a:endParaRPr lang="en-US" sz="1500" dirty="0"/>
           </a:p>
@@ -8173,7 +8118,7 @@
                             <a:schemeClr val="tx1"/>
                           </a:solidFill>
                         </a:rPr>
-                        <a:t>SoGhe</a:t>
+                        <a:t>SucChua</a:t>
                       </a:r>
                       <a:endParaRPr lang="en-US" sz="1000" dirty="0"/>
                     </a:p>

</xml_diff>

<commit_message>
Slide 4: hand-drawn style ER diagram
Render the Chen ER diagram (with weak entity VE) in a sketch style using
rough.js and a handwriting font, generated from the same ER model, and
place it on slide 4. Replaces the previous standalone PNG.

Co-Authored-By: Claude Opus 5.5 <noreply@anthropic.com>
Claude-Session: https://claude.ai/code/session_01Mv7zheFMCNi8CpghoGk7yL
</commit_message>
<xml_diff>
--- a/hqtcsdl-giuaky/quan_ly_rap_phim.pptx
+++ b/hqtcsdl-giuaky/quan_ly_rap_phim.pptx
@@ -114,26 +114,26 @@
   <p:extLst>
     <p:ext uri="{521415D9-36F7-43E2-AB2F-B90AF26B5E84}">
       <p14:sectionLst xmlns:p14="http://schemas.microsoft.com/office/powerpoint/2010/main">
-        <p14:section name="Mở đầu" id="{79094d74-55c0-d00c-0f3e-888290b579f2}">
+        <p14:section name="Mở đầu" id="{d009a2b2-ff51-004a-a875-ce4fe05414dc}">
           <p14:sldIdLst>
             <p14:sldId id="256"/>
             <p14:sldId id="257"/>
           </p14:sldIdLst>
         </p14:section>
-        <p14:section name="Phân tích và thiết kế" id="{dac4d42e-a018-7637-5f77-154e238ee1d3}">
+        <p14:section name="Phân tích và thiết kế" id="{05cdb93d-f563-93b8-aea9-80de5d22f3f0}">
           <p14:sldIdLst>
             <p14:sldId id="258"/>
             <p14:sldId id="259"/>
             <p14:sldId id="260"/>
           </p14:sldIdLst>
         </p14:section>
-        <p14:section name="Cài đặt" id="{414bcc83-f3d3-c12e-ecc8-5fb85ccb413a}">
+        <p14:section name="Cài đặt" id="{53cc9ad9-e562-2af1-baea-08d112efde0a}">
           <p14:sldIdLst>
             <p14:sldId id="261"/>
             <p14:sldId id="262"/>
           </p14:sldIdLst>
         </p14:section>
-        <p14:section name="Kết thúc" id="{35664195-e91a-9e2c-75a8-4767cb9fde64}">
+        <p14:section name="Kết thúc" id="{015d0677-7837-df97-7e53-7c914259c4bc}">
           <p14:sldIdLst>
             <p14:sldId id="263"/>
           </p14:sldIdLst>
@@ -4931,2726 +4931,30 @@
           </a:p>
         </p:txBody>
       </p:sp>
-      <p:sp>
-        <p:nvSpPr>
-          <p:cNvPr id="3" name="Shape 1"/>
-          <p:cNvSpPr/>
+      <p:pic>
+        <p:nvPicPr>
+          <p:cNvPr id="3" name="ER diagram hand-drawn" descr="Mô hình ER vẽ tay theo ký hiệu Chen: 4 thực thể mạnh, thực thể yếu VE, 4 quan hệ 1-N">    </p:cNvPr>
+          <p:cNvPicPr>
+            <a:picLocks noChangeAspect="1"/>
+          </p:cNvPicPr>
           <p:nvPr/>
-        </p:nvSpPr>
+        </p:nvPicPr>
+        <p:blipFill>
+          <a:blip r:embed="rId1"/>
+          <a:stretch>
+            <a:fillRect/>
+          </a:stretch>
+        </p:blipFill>
         <p:spPr>
           <a:xfrm>
-            <a:off x="777240" y="1600200"/>
-            <a:ext cx="960120" cy="1143000"/>
-          </a:xfrm>
-          <a:prstGeom prst="line">
-            <a:avLst/>
-          </a:prstGeom>
-          <a:noFill/>
-          <a:ln w="12700">
-            <a:solidFill>
-              <a:schemeClr val="tx1"/>
-            </a:solidFill>
-            <a:prstDash val="solid"/>
-          </a:ln>
-        </p:spPr>
-      </p:sp>
-      <p:sp>
-        <p:nvSpPr>
-          <p:cNvPr id="4" name="Shape 2"/>
-          <p:cNvSpPr/>
-          <p:nvPr/>
-        </p:nvSpPr>
-        <p:spPr>
-          <a:xfrm flipV="1">
-            <a:off x="1737360" y="1463040"/>
-            <a:ext cx="411480" cy="1280160"/>
-          </a:xfrm>
-          <a:prstGeom prst="line">
-            <a:avLst/>
-          </a:prstGeom>
-          <a:noFill/>
-          <a:ln w="12700">
-            <a:solidFill>
-              <a:schemeClr val="tx1"/>
-            </a:solidFill>
-            <a:prstDash val="solid"/>
-          </a:ln>
-        </p:spPr>
-      </p:sp>
-      <p:sp>
-        <p:nvSpPr>
-          <p:cNvPr id="5" name="Shape 3"/>
-          <p:cNvSpPr/>
-          <p:nvPr/>
-        </p:nvSpPr>
-        <p:spPr>
-          <a:xfrm flipV="1">
-            <a:off x="1737360" y="1645920"/>
-            <a:ext cx="1691640" cy="1097280"/>
-          </a:xfrm>
-          <a:prstGeom prst="line">
-            <a:avLst/>
-          </a:prstGeom>
-          <a:noFill/>
-          <a:ln w="12700">
-            <a:solidFill>
-              <a:schemeClr val="tx1"/>
-            </a:solidFill>
-            <a:prstDash val="solid"/>
-          </a:ln>
-        </p:spPr>
-      </p:sp>
-      <p:sp>
-        <p:nvSpPr>
-          <p:cNvPr id="6" name="Shape 4"/>
-          <p:cNvSpPr/>
-          <p:nvPr/>
-        </p:nvSpPr>
-        <p:spPr>
-          <a:xfrm flipV="1">
-            <a:off x="960120" y="2743200"/>
-            <a:ext cx="777240" cy="1005840"/>
-          </a:xfrm>
-          <a:prstGeom prst="line">
-            <a:avLst/>
-          </a:prstGeom>
-          <a:noFill/>
-          <a:ln w="12700">
-            <a:solidFill>
-              <a:schemeClr val="tx1"/>
-            </a:solidFill>
-            <a:prstDash val="solid"/>
-          </a:ln>
-        </p:spPr>
-      </p:sp>
-      <p:sp>
-        <p:nvSpPr>
-          <p:cNvPr id="7" name="Shape 5"/>
-          <p:cNvSpPr/>
-          <p:nvPr/>
-        </p:nvSpPr>
-        <p:spPr>
-          <a:xfrm>
-            <a:off x="1737360" y="2743200"/>
-            <a:ext cx="731520" cy="1005840"/>
-          </a:xfrm>
-          <a:prstGeom prst="line">
-            <a:avLst/>
-          </a:prstGeom>
-          <a:noFill/>
-          <a:ln w="12700">
-            <a:solidFill>
-              <a:schemeClr val="tx1"/>
-            </a:solidFill>
-            <a:prstDash val="solid"/>
-          </a:ln>
-        </p:spPr>
-      </p:sp>
-      <p:sp>
-        <p:nvSpPr>
-          <p:cNvPr id="8" name="Shape 6"/>
-          <p:cNvSpPr/>
-          <p:nvPr/>
-        </p:nvSpPr>
-        <p:spPr>
-          <a:xfrm>
-            <a:off x="9692640" y="1554480"/>
-            <a:ext cx="731520" cy="1188720"/>
-          </a:xfrm>
-          <a:prstGeom prst="line">
-            <a:avLst/>
-          </a:prstGeom>
-          <a:noFill/>
-          <a:ln w="12700">
-            <a:solidFill>
-              <a:schemeClr val="tx1"/>
-            </a:solidFill>
-            <a:prstDash val="solid"/>
-          </a:ln>
-        </p:spPr>
-      </p:sp>
-      <p:sp>
-        <p:nvSpPr>
-          <p:cNvPr id="9" name="Shape 7"/>
-          <p:cNvSpPr/>
-          <p:nvPr/>
-        </p:nvSpPr>
-        <p:spPr>
-          <a:xfrm flipV="1">
-            <a:off x="10424160" y="1554480"/>
-            <a:ext cx="731520" cy="1188720"/>
-          </a:xfrm>
-          <a:prstGeom prst="line">
-            <a:avLst/>
-          </a:prstGeom>
-          <a:noFill/>
-          <a:ln w="12700">
-            <a:solidFill>
-              <a:schemeClr val="tx1"/>
-            </a:solidFill>
-            <a:prstDash val="solid"/>
-          </a:ln>
-        </p:spPr>
-      </p:sp>
-      <p:sp>
-        <p:nvSpPr>
-          <p:cNvPr id="10" name="Shape 8"/>
-          <p:cNvSpPr/>
-          <p:nvPr/>
-        </p:nvSpPr>
-        <p:spPr>
-          <a:xfrm flipV="1">
-            <a:off x="9692640" y="2743200"/>
-            <a:ext cx="731520" cy="1005840"/>
-          </a:xfrm>
-          <a:prstGeom prst="line">
-            <a:avLst/>
-          </a:prstGeom>
-          <a:noFill/>
-          <a:ln w="12700">
-            <a:solidFill>
-              <a:schemeClr val="tx1"/>
-            </a:solidFill>
-            <a:prstDash val="solid"/>
-          </a:ln>
-        </p:spPr>
-      </p:sp>
-      <p:sp>
-        <p:nvSpPr>
-          <p:cNvPr id="11" name="Shape 9"/>
-          <p:cNvSpPr/>
-          <p:nvPr/>
-        </p:nvSpPr>
-        <p:spPr>
-          <a:xfrm>
-            <a:off x="10424160" y="2743200"/>
-            <a:ext cx="731520" cy="1005840"/>
-          </a:xfrm>
-          <a:prstGeom prst="line">
-            <a:avLst/>
-          </a:prstGeom>
-          <a:noFill/>
-          <a:ln w="12700">
-            <a:solidFill>
-              <a:schemeClr val="tx1"/>
-            </a:solidFill>
-            <a:prstDash val="solid"/>
-          </a:ln>
-        </p:spPr>
-      </p:sp>
-      <p:sp>
-        <p:nvSpPr>
-          <p:cNvPr id="12" name="Shape 10"/>
-          <p:cNvSpPr/>
-          <p:nvPr/>
-        </p:nvSpPr>
-        <p:spPr>
-          <a:xfrm>
-            <a:off x="5349240" y="1554480"/>
-            <a:ext cx="749808" cy="1188720"/>
-          </a:xfrm>
-          <a:prstGeom prst="line">
-            <a:avLst/>
-          </a:prstGeom>
-          <a:noFill/>
-          <a:ln w="12700">
-            <a:solidFill>
-              <a:schemeClr val="tx1"/>
-            </a:solidFill>
-            <a:prstDash val="solid"/>
-          </a:ln>
-        </p:spPr>
-      </p:sp>
-      <p:sp>
-        <p:nvSpPr>
-          <p:cNvPr id="13" name="Shape 11"/>
-          <p:cNvSpPr/>
-          <p:nvPr/>
-        </p:nvSpPr>
-        <p:spPr>
-          <a:xfrm flipV="1">
-            <a:off x="6099048" y="1554480"/>
-            <a:ext cx="713232" cy="1188720"/>
-          </a:xfrm>
-          <a:prstGeom prst="line">
-            <a:avLst/>
-          </a:prstGeom>
-          <a:noFill/>
-          <a:ln w="12700">
-            <a:solidFill>
-              <a:schemeClr val="tx1"/>
-            </a:solidFill>
-            <a:prstDash val="solid"/>
-          </a:ln>
-        </p:spPr>
-      </p:sp>
-      <p:sp>
-        <p:nvSpPr>
-          <p:cNvPr id="14" name="Shape 12"/>
-          <p:cNvSpPr/>
-          <p:nvPr/>
-        </p:nvSpPr>
-        <p:spPr>
-          <a:xfrm flipV="1">
-            <a:off x="4709160" y="2743200"/>
-            <a:ext cx="1389888" cy="960120"/>
-          </a:xfrm>
-          <a:prstGeom prst="line">
-            <a:avLst/>
-          </a:prstGeom>
-          <a:noFill/>
-          <a:ln w="12700">
-            <a:solidFill>
-              <a:schemeClr val="tx1"/>
-            </a:solidFill>
-            <a:prstDash val="solid"/>
-          </a:ln>
-        </p:spPr>
-      </p:sp>
-      <p:sp>
-        <p:nvSpPr>
-          <p:cNvPr id="15" name="Shape 13"/>
-          <p:cNvSpPr/>
-          <p:nvPr/>
-        </p:nvSpPr>
-        <p:spPr>
-          <a:xfrm>
-            <a:off x="6099048" y="2743200"/>
-            <a:ext cx="1399032" cy="960120"/>
-          </a:xfrm>
-          <a:prstGeom prst="line">
-            <a:avLst/>
-          </a:prstGeom>
-          <a:noFill/>
-          <a:ln w="12700">
-            <a:solidFill>
-              <a:schemeClr val="tx1"/>
-            </a:solidFill>
-            <a:prstDash val="solid"/>
-          </a:ln>
-        </p:spPr>
-      </p:sp>
-      <p:sp>
-        <p:nvSpPr>
-          <p:cNvPr id="16" name="Shape 14"/>
-          <p:cNvSpPr/>
-          <p:nvPr/>
-        </p:nvSpPr>
-        <p:spPr>
-          <a:xfrm flipV="1">
-            <a:off x="777240" y="5212080"/>
-            <a:ext cx="960120" cy="914400"/>
-          </a:xfrm>
-          <a:prstGeom prst="line">
-            <a:avLst/>
-          </a:prstGeom>
-          <a:noFill/>
-          <a:ln w="12700">
-            <a:solidFill>
-              <a:schemeClr val="tx1"/>
-            </a:solidFill>
-            <a:prstDash val="solid"/>
-          </a:ln>
-        </p:spPr>
-      </p:sp>
-      <p:sp>
-        <p:nvSpPr>
-          <p:cNvPr id="17" name="Shape 15"/>
-          <p:cNvSpPr/>
-          <p:nvPr/>
-        </p:nvSpPr>
-        <p:spPr>
-          <a:xfrm>
-            <a:off x="1737360" y="5212080"/>
-            <a:ext cx="411480" cy="914400"/>
-          </a:xfrm>
-          <a:prstGeom prst="line">
-            <a:avLst/>
-          </a:prstGeom>
-          <a:noFill/>
-          <a:ln w="12700">
-            <a:solidFill>
-              <a:schemeClr val="tx1"/>
-            </a:solidFill>
-            <a:prstDash val="solid"/>
-          </a:ln>
-        </p:spPr>
-      </p:sp>
-      <p:sp>
-        <p:nvSpPr>
-          <p:cNvPr id="18" name="Shape 16"/>
-          <p:cNvSpPr/>
-          <p:nvPr/>
-        </p:nvSpPr>
-        <p:spPr>
-          <a:xfrm>
-            <a:off x="1737360" y="5212080"/>
-            <a:ext cx="1737360" cy="914400"/>
-          </a:xfrm>
-          <a:prstGeom prst="line">
-            <a:avLst/>
-          </a:prstGeom>
-          <a:noFill/>
-          <a:ln w="12700">
-            <a:solidFill>
-              <a:schemeClr val="tx1"/>
-            </a:solidFill>
-            <a:prstDash val="solid"/>
-          </a:ln>
-        </p:spPr>
-      </p:sp>
-      <p:sp>
-        <p:nvSpPr>
-          <p:cNvPr id="19" name="Shape 17"/>
-          <p:cNvSpPr/>
-          <p:nvPr/>
-        </p:nvSpPr>
-        <p:spPr>
-          <a:xfrm>
-            <a:off x="731520" y="4434840"/>
-            <a:ext cx="1005840" cy="777240"/>
-          </a:xfrm>
-          <a:prstGeom prst="line">
-            <a:avLst/>
-          </a:prstGeom>
-          <a:noFill/>
-          <a:ln w="12700">
-            <a:solidFill>
-              <a:schemeClr val="tx1"/>
-            </a:solidFill>
-            <a:prstDash val="solid"/>
-          </a:ln>
-        </p:spPr>
-      </p:sp>
-      <p:sp>
-        <p:nvSpPr>
-          <p:cNvPr id="20" name="Shape 18"/>
-          <p:cNvSpPr/>
-          <p:nvPr/>
-        </p:nvSpPr>
-        <p:spPr>
-          <a:xfrm flipV="1">
-            <a:off x="5486400" y="5212080"/>
-            <a:ext cx="612648" cy="914400"/>
-          </a:xfrm>
-          <a:prstGeom prst="line">
-            <a:avLst/>
-          </a:prstGeom>
-          <a:noFill/>
-          <a:ln w="12700">
-            <a:solidFill>
-              <a:schemeClr val="tx1"/>
-            </a:solidFill>
-            <a:prstDash val="solid"/>
-          </a:ln>
-        </p:spPr>
-      </p:sp>
-      <p:sp>
-        <p:nvSpPr>
-          <p:cNvPr id="21" name="Shape 19"/>
-          <p:cNvSpPr/>
-          <p:nvPr/>
-        </p:nvSpPr>
-        <p:spPr>
-          <a:xfrm>
-            <a:off x="6099048" y="5212080"/>
-            <a:ext cx="758952" cy="914400"/>
-          </a:xfrm>
-          <a:prstGeom prst="line">
-            <a:avLst/>
-          </a:prstGeom>
-          <a:noFill/>
-          <a:ln w="12700">
-            <a:solidFill>
-              <a:schemeClr val="tx1"/>
-            </a:solidFill>
-            <a:prstDash val="solid"/>
-          </a:ln>
-        </p:spPr>
-      </p:sp>
-      <p:sp>
-        <p:nvSpPr>
-          <p:cNvPr id="22" name="Shape 20"/>
-          <p:cNvSpPr/>
-          <p:nvPr/>
-        </p:nvSpPr>
-        <p:spPr>
-          <a:xfrm>
-            <a:off x="1737360" y="2743200"/>
-            <a:ext cx="2176272" cy="0"/>
-          </a:xfrm>
-          <a:prstGeom prst="line">
-            <a:avLst/>
-          </a:prstGeom>
-          <a:noFill/>
-          <a:ln w="25400">
-            <a:solidFill>
-              <a:schemeClr val="tx1"/>
-            </a:solidFill>
-            <a:prstDash val="solid"/>
-          </a:ln>
-        </p:spPr>
-      </p:sp>
-      <p:sp>
-        <p:nvSpPr>
-          <p:cNvPr id="23" name="Shape 21"/>
-          <p:cNvSpPr/>
-          <p:nvPr/>
-        </p:nvSpPr>
-        <p:spPr>
-          <a:xfrm>
-            <a:off x="3913632" y="2743200"/>
-            <a:ext cx="2185416" cy="0"/>
-          </a:xfrm>
-          <a:prstGeom prst="line">
-            <a:avLst/>
-          </a:prstGeom>
-          <a:noFill/>
-          <a:ln w="25400">
-            <a:solidFill>
-              <a:schemeClr val="tx1"/>
-            </a:solidFill>
-            <a:prstDash val="solid"/>
-          </a:ln>
-        </p:spPr>
-      </p:sp>
-      <p:sp>
-        <p:nvSpPr>
-          <p:cNvPr id="24" name="Shape 22"/>
-          <p:cNvSpPr/>
-          <p:nvPr/>
-        </p:nvSpPr>
-        <p:spPr>
-          <a:xfrm>
-            <a:off x="8275320" y="2743200"/>
-            <a:ext cx="2148840" cy="0"/>
-          </a:xfrm>
-          <a:prstGeom prst="line">
-            <a:avLst/>
-          </a:prstGeom>
-          <a:noFill/>
-          <a:ln w="25400">
-            <a:solidFill>
-              <a:schemeClr val="tx1"/>
-            </a:solidFill>
-            <a:prstDash val="solid"/>
-          </a:ln>
-        </p:spPr>
-      </p:sp>
-      <p:sp>
-        <p:nvSpPr>
-          <p:cNvPr id="25" name="Shape 23"/>
-          <p:cNvSpPr/>
-          <p:nvPr/>
-        </p:nvSpPr>
-        <p:spPr>
-          <a:xfrm>
-            <a:off x="6099048" y="2743200"/>
-            <a:ext cx="2176272" cy="0"/>
-          </a:xfrm>
-          <a:prstGeom prst="line">
-            <a:avLst/>
-          </a:prstGeom>
-          <a:noFill/>
-          <a:ln w="25400">
-            <a:solidFill>
-              <a:schemeClr val="tx1"/>
-            </a:solidFill>
-            <a:prstDash val="solid"/>
-          </a:ln>
-        </p:spPr>
-      </p:sp>
-      <p:sp>
-        <p:nvSpPr>
-          <p:cNvPr id="26" name="Shape 24"/>
-          <p:cNvSpPr/>
-          <p:nvPr/>
-        </p:nvSpPr>
-        <p:spPr>
-          <a:xfrm>
-            <a:off x="6099048" y="2743200"/>
-            <a:ext cx="0" cy="1234440"/>
-          </a:xfrm>
-          <a:prstGeom prst="line">
-            <a:avLst/>
-          </a:prstGeom>
-          <a:noFill/>
-          <a:ln w="25400">
-            <a:solidFill>
-              <a:schemeClr val="tx1"/>
-            </a:solidFill>
-            <a:prstDash val="solid"/>
-          </a:ln>
-        </p:spPr>
-      </p:sp>
-      <p:sp>
-        <p:nvSpPr>
-          <p:cNvPr id="27" name="Shape 25"/>
-          <p:cNvSpPr/>
-          <p:nvPr/>
-        </p:nvSpPr>
-        <p:spPr>
-          <a:xfrm>
-            <a:off x="6053328" y="3977640"/>
-            <a:ext cx="0" cy="1234440"/>
-          </a:xfrm>
-          <a:prstGeom prst="line">
-            <a:avLst/>
-          </a:prstGeom>
-          <a:noFill/>
-          <a:ln w="19050">
-            <a:solidFill>
-              <a:schemeClr val="tx1"/>
-            </a:solidFill>
-            <a:prstDash val="solid"/>
-          </a:ln>
-        </p:spPr>
-      </p:sp>
-      <p:sp>
-        <p:nvSpPr>
-          <p:cNvPr id="28" name="Shape 26"/>
-          <p:cNvSpPr/>
-          <p:nvPr/>
-        </p:nvSpPr>
-        <p:spPr>
-          <a:xfrm>
-            <a:off x="6144768" y="3977640"/>
-            <a:ext cx="0" cy="1234440"/>
-          </a:xfrm>
-          <a:prstGeom prst="line">
-            <a:avLst/>
-          </a:prstGeom>
-          <a:noFill/>
-          <a:ln w="19050">
-            <a:solidFill>
-              <a:schemeClr val="tx1"/>
-            </a:solidFill>
-            <a:prstDash val="solid"/>
-          </a:ln>
-        </p:spPr>
-      </p:sp>
-      <p:sp>
-        <p:nvSpPr>
-          <p:cNvPr id="29" name="Shape 27"/>
-          <p:cNvSpPr/>
-          <p:nvPr/>
-        </p:nvSpPr>
-        <p:spPr>
-          <a:xfrm>
-            <a:off x="1737360" y="5212080"/>
-            <a:ext cx="2176272" cy="0"/>
-          </a:xfrm>
-          <a:prstGeom prst="line">
-            <a:avLst/>
-          </a:prstGeom>
-          <a:noFill/>
-          <a:ln w="25400">
-            <a:solidFill>
-              <a:schemeClr val="tx1"/>
-            </a:solidFill>
-            <a:prstDash val="solid"/>
-          </a:ln>
-        </p:spPr>
-      </p:sp>
-      <p:sp>
-        <p:nvSpPr>
-          <p:cNvPr id="30" name="Shape 28"/>
-          <p:cNvSpPr/>
-          <p:nvPr/>
-        </p:nvSpPr>
-        <p:spPr>
-          <a:xfrm>
-            <a:off x="3913632" y="5212080"/>
-            <a:ext cx="2185416" cy="0"/>
-          </a:xfrm>
-          <a:prstGeom prst="line">
-            <a:avLst/>
-          </a:prstGeom>
-          <a:noFill/>
-          <a:ln w="25400">
-            <a:solidFill>
-              <a:schemeClr val="tx1"/>
-            </a:solidFill>
-            <a:prstDash val="solid"/>
-          </a:ln>
-        </p:spPr>
-      </p:sp>
-      <p:sp>
-        <p:nvSpPr>
-          <p:cNvPr id="31" name="Cardinality 1 PHIM"/>
-          <p:cNvSpPr txBox="1"/>
-          <p:nvPr/>
-        </p:nvSpPr>
-        <p:spPr>
-          <a:xfrm>
-            <a:off x="2583180" y="2441448"/>
-            <a:ext cx="228600" cy="256032"/>
+            <a:off x="0" y="1143000"/>
+            <a:ext cx="12191695" cy="5257800"/>
           </a:xfrm>
           <a:prstGeom prst="rect">
             <a:avLst/>
           </a:prstGeom>
-          <a:noFill/>
-          <a:ln/>
         </p:spPr>
-        <p:txBody>
-          <a:bodyPr wrap="square" lIns="0" tIns="0" rIns="0" bIns="0" rtlCol="0" anchor="t"/>
-          <a:lstStyle/>
-          <a:p>
-            <a:pPr algn="ctr" indent="0" marL="0">
-              <a:buNone/>
-            </a:pPr>
-            <a:r>
-              <a:rPr lang="en-US" sz="1400" b="1" dirty="0">
-                <a:solidFill>
-                  <a:schemeClr val="tx1"/>
-                </a:solidFill>
-              </a:rPr>
-              <a:t>1</a:t>
-            </a:r>
-            <a:endParaRPr lang="en-US" sz="1400" dirty="0"/>
-          </a:p>
-        </p:txBody>
-      </p:sp>
-      <p:sp>
-        <p:nvSpPr>
-          <p:cNvPr id="32" name="Cardinality N SUATCHIEU"/>
-          <p:cNvSpPr txBox="1"/>
-          <p:nvPr/>
-        </p:nvSpPr>
-        <p:spPr>
-          <a:xfrm>
-            <a:off x="5024628" y="2441448"/>
-            <a:ext cx="228600" cy="256032"/>
-          </a:xfrm>
-          <a:prstGeom prst="rect">
-            <a:avLst/>
-          </a:prstGeom>
-          <a:noFill/>
-          <a:ln/>
-        </p:spPr>
-        <p:txBody>
-          <a:bodyPr wrap="square" lIns="0" tIns="0" rIns="0" bIns="0" rtlCol="0" anchor="t"/>
-          <a:lstStyle/>
-          <a:p>
-            <a:pPr algn="ctr" indent="0" marL="0">
-              <a:buNone/>
-            </a:pPr>
-            <a:r>
-              <a:rPr lang="en-US" sz="1400" b="1" dirty="0">
-                <a:solidFill>
-                  <a:schemeClr val="tx1"/>
-                </a:solidFill>
-              </a:rPr>
-              <a:t>N</a:t>
-            </a:r>
-            <a:endParaRPr lang="en-US" sz="1400" dirty="0"/>
-          </a:p>
-        </p:txBody>
-      </p:sp>
-      <p:sp>
-        <p:nvSpPr>
-          <p:cNvPr id="33" name="Cardinality 1 PHONGCHIEU"/>
-          <p:cNvSpPr txBox="1"/>
-          <p:nvPr/>
-        </p:nvSpPr>
-        <p:spPr>
-          <a:xfrm>
-            <a:off x="9349740" y="2441448"/>
-            <a:ext cx="228600" cy="256032"/>
-          </a:xfrm>
-          <a:prstGeom prst="rect">
-            <a:avLst/>
-          </a:prstGeom>
-          <a:noFill/>
-          <a:ln/>
-        </p:spPr>
-        <p:txBody>
-          <a:bodyPr wrap="square" lIns="0" tIns="0" rIns="0" bIns="0" rtlCol="0" anchor="t"/>
-          <a:lstStyle/>
-          <a:p>
-            <a:pPr algn="ctr" indent="0" marL="0">
-              <a:buNone/>
-            </a:pPr>
-            <a:r>
-              <a:rPr lang="en-US" sz="1400" b="1" dirty="0">
-                <a:solidFill>
-                  <a:schemeClr val="tx1"/>
-                </a:solidFill>
-              </a:rPr>
-              <a:t>1</a:t>
-            </a:r>
-            <a:endParaRPr lang="en-US" sz="1400" dirty="0"/>
-          </a:p>
-        </p:txBody>
-      </p:sp>
-      <p:sp>
-        <p:nvSpPr>
-          <p:cNvPr id="34" name="Cardinality N SUATCHIEU"/>
-          <p:cNvSpPr txBox="1"/>
-          <p:nvPr/>
-        </p:nvSpPr>
-        <p:spPr>
-          <a:xfrm>
-            <a:off x="6944868" y="2441448"/>
-            <a:ext cx="228600" cy="256032"/>
-          </a:xfrm>
-          <a:prstGeom prst="rect">
-            <a:avLst/>
-          </a:prstGeom>
-          <a:noFill/>
-          <a:ln/>
-        </p:spPr>
-        <p:txBody>
-          <a:bodyPr wrap="square" lIns="0" tIns="0" rIns="0" bIns="0" rtlCol="0" anchor="t"/>
-          <a:lstStyle/>
-          <a:p>
-            <a:pPr algn="ctr" indent="0" marL="0">
-              <a:buNone/>
-            </a:pPr>
-            <a:r>
-              <a:rPr lang="en-US" sz="1400" b="1" dirty="0">
-                <a:solidFill>
-                  <a:schemeClr val="tx1"/>
-                </a:solidFill>
-              </a:rPr>
-              <a:t>N</a:t>
-            </a:r>
-            <a:endParaRPr lang="en-US" sz="1400" dirty="0"/>
-          </a:p>
-        </p:txBody>
-      </p:sp>
-      <p:sp>
-        <p:nvSpPr>
-          <p:cNvPr id="35" name="Cardinality 1 SUATCHIEU"/>
-          <p:cNvSpPr txBox="1"/>
-          <p:nvPr/>
-        </p:nvSpPr>
-        <p:spPr>
-          <a:xfrm>
-            <a:off x="5769864" y="3012948"/>
-            <a:ext cx="228600" cy="256032"/>
-          </a:xfrm>
-          <a:prstGeom prst="rect">
-            <a:avLst/>
-          </a:prstGeom>
-          <a:noFill/>
-          <a:ln/>
-        </p:spPr>
-        <p:txBody>
-          <a:bodyPr wrap="square" lIns="0" tIns="0" rIns="0" bIns="0" rtlCol="0" anchor="t"/>
-          <a:lstStyle/>
-          <a:p>
-            <a:pPr algn="ctr" indent="0" marL="0">
-              <a:buNone/>
-            </a:pPr>
-            <a:r>
-              <a:rPr lang="en-US" sz="1400" b="1" dirty="0">
-                <a:solidFill>
-                  <a:schemeClr val="tx1"/>
-                </a:solidFill>
-              </a:rPr>
-              <a:t>1</a:t>
-            </a:r>
-            <a:endParaRPr lang="en-US" sz="1400" dirty="0"/>
-          </a:p>
-        </p:txBody>
-      </p:sp>
-      <p:sp>
-        <p:nvSpPr>
-          <p:cNvPr id="36" name="Cardinality N VE"/>
-          <p:cNvSpPr txBox="1"/>
-          <p:nvPr/>
-        </p:nvSpPr>
-        <p:spPr>
-          <a:xfrm>
-            <a:off x="5769864" y="4686300"/>
-            <a:ext cx="228600" cy="256032"/>
-          </a:xfrm>
-          <a:prstGeom prst="rect">
-            <a:avLst/>
-          </a:prstGeom>
-          <a:noFill/>
-          <a:ln/>
-        </p:spPr>
-        <p:txBody>
-          <a:bodyPr wrap="square" lIns="0" tIns="0" rIns="0" bIns="0" rtlCol="0" anchor="t"/>
-          <a:lstStyle/>
-          <a:p>
-            <a:pPr algn="ctr" indent="0" marL="0">
-              <a:buNone/>
-            </a:pPr>
-            <a:r>
-              <a:rPr lang="en-US" sz="1400" b="1" dirty="0">
-                <a:solidFill>
-                  <a:schemeClr val="tx1"/>
-                </a:solidFill>
-              </a:rPr>
-              <a:t>N</a:t>
-            </a:r>
-            <a:endParaRPr lang="en-US" sz="1400" dirty="0"/>
-          </a:p>
-        </p:txBody>
-      </p:sp>
-      <p:sp>
-        <p:nvSpPr>
-          <p:cNvPr id="37" name="Cardinality 1 KHACHHANG"/>
-          <p:cNvSpPr txBox="1"/>
-          <p:nvPr/>
-        </p:nvSpPr>
-        <p:spPr>
-          <a:xfrm>
-            <a:off x="2583180" y="4910328"/>
-            <a:ext cx="228600" cy="256032"/>
-          </a:xfrm>
-          <a:prstGeom prst="rect">
-            <a:avLst/>
-          </a:prstGeom>
-          <a:noFill/>
-          <a:ln/>
-        </p:spPr>
-        <p:txBody>
-          <a:bodyPr wrap="square" lIns="0" tIns="0" rIns="0" bIns="0" rtlCol="0" anchor="t"/>
-          <a:lstStyle/>
-          <a:p>
-            <a:pPr algn="ctr" indent="0" marL="0">
-              <a:buNone/>
-            </a:pPr>
-            <a:r>
-              <a:rPr lang="en-US" sz="1400" b="1" dirty="0">
-                <a:solidFill>
-                  <a:schemeClr val="tx1"/>
-                </a:solidFill>
-              </a:rPr>
-              <a:t>1</a:t>
-            </a:r>
-            <a:endParaRPr lang="en-US" sz="1400" dirty="0"/>
-          </a:p>
-        </p:txBody>
-      </p:sp>
-      <p:sp>
-        <p:nvSpPr>
-          <p:cNvPr id="38" name="Cardinality N VE"/>
-          <p:cNvSpPr txBox="1"/>
-          <p:nvPr/>
-        </p:nvSpPr>
-        <p:spPr>
-          <a:xfrm>
-            <a:off x="5024628" y="4910328"/>
-            <a:ext cx="228600" cy="256032"/>
-          </a:xfrm>
-          <a:prstGeom prst="rect">
-            <a:avLst/>
-          </a:prstGeom>
-          <a:noFill/>
-          <a:ln/>
-        </p:spPr>
-        <p:txBody>
-          <a:bodyPr wrap="square" lIns="0" tIns="0" rIns="0" bIns="0" rtlCol="0" anchor="t"/>
-          <a:lstStyle/>
-          <a:p>
-            <a:pPr algn="ctr" indent="0" marL="0">
-              <a:buNone/>
-            </a:pPr>
-            <a:r>
-              <a:rPr lang="en-US" sz="1400" b="1" dirty="0">
-                <a:solidFill>
-                  <a:schemeClr val="tx1"/>
-                </a:solidFill>
-              </a:rPr>
-              <a:t>N</a:t>
-            </a:r>
-            <a:endParaRPr lang="en-US" sz="1400" dirty="0"/>
-          </a:p>
-        </p:txBody>
-      </p:sp>
-      <p:sp>
-        <p:nvSpPr>
-          <p:cNvPr id="39" name="Attr PHIM MaPhim"/>
-          <p:cNvSpPr/>
-          <p:nvPr/>
-        </p:nvSpPr>
-        <p:spPr>
-          <a:xfrm>
-            <a:off x="114300" y="1408176"/>
-            <a:ext cx="1325880" cy="384048"/>
-          </a:xfrm>
-          <a:prstGeom prst="ellipse">
-            <a:avLst/>
-          </a:prstGeom>
-          <a:solidFill>
-            <a:schemeClr val="bg1"/>
-          </a:solidFill>
-          <a:ln w="12700">
-            <a:solidFill>
-              <a:schemeClr val="tx2"/>
-            </a:solidFill>
-          </a:ln>
-        </p:spPr>
-        <p:txBody>
-          <a:bodyPr wrap="square" lIns="0" tIns="0" rIns="0" bIns="0" rtlCol="0" anchor="ctr"/>
-          <a:lstStyle/>
-          <a:p>
-            <a:pPr algn="ctr" indent="0" marL="0">
-              <a:buNone/>
-            </a:pPr>
-            <a:r>
-              <a:rPr lang="en-US" sz="1100" b="1" u="sng" dirty="0">
-                <a:solidFill>
-                  <a:schemeClr val="tx1"/>
-                </a:solidFill>
-              </a:rPr>
-              <a:t>MaPhim</a:t>
-            </a:r>
-            <a:endParaRPr lang="en-US" sz="1100" dirty="0"/>
-          </a:p>
-        </p:txBody>
-      </p:sp>
-      <p:sp>
-        <p:nvSpPr>
-          <p:cNvPr id="40" name="Attr PHIM TenPhim"/>
-          <p:cNvSpPr/>
-          <p:nvPr/>
-        </p:nvSpPr>
-        <p:spPr>
-          <a:xfrm>
-            <a:off x="1485900" y="1271016"/>
-            <a:ext cx="1325880" cy="384048"/>
-          </a:xfrm>
-          <a:prstGeom prst="ellipse">
-            <a:avLst/>
-          </a:prstGeom>
-          <a:solidFill>
-            <a:schemeClr val="bg1"/>
-          </a:solidFill>
-          <a:ln w="12700">
-            <a:solidFill>
-              <a:schemeClr val="tx2"/>
-            </a:solidFill>
-          </a:ln>
-        </p:spPr>
-        <p:txBody>
-          <a:bodyPr wrap="square" lIns="0" tIns="0" rIns="0" bIns="0" rtlCol="0" anchor="ctr"/>
-          <a:lstStyle/>
-          <a:p>
-            <a:pPr algn="ctr" indent="0" marL="0">
-              <a:buNone/>
-            </a:pPr>
-            <a:r>
-              <a:rPr lang="en-US" sz="1100" dirty="0">
-                <a:solidFill>
-                  <a:schemeClr val="tx1"/>
-                </a:solidFill>
-              </a:rPr>
-              <a:t>TenPhim</a:t>
-            </a:r>
-            <a:endParaRPr lang="en-US" sz="1100" dirty="0"/>
-          </a:p>
-        </p:txBody>
-      </p:sp>
-      <p:sp>
-        <p:nvSpPr>
-          <p:cNvPr id="41" name="Attr PHIM TheLoai"/>
-          <p:cNvSpPr/>
-          <p:nvPr/>
-        </p:nvSpPr>
-        <p:spPr>
-          <a:xfrm>
-            <a:off x="2766060" y="1453896"/>
-            <a:ext cx="1325880" cy="384048"/>
-          </a:xfrm>
-          <a:prstGeom prst="ellipse">
-            <a:avLst/>
-          </a:prstGeom>
-          <a:solidFill>
-            <a:schemeClr val="bg1"/>
-          </a:solidFill>
-          <a:ln w="12700">
-            <a:solidFill>
-              <a:schemeClr val="tx2"/>
-            </a:solidFill>
-          </a:ln>
-        </p:spPr>
-        <p:txBody>
-          <a:bodyPr wrap="square" lIns="0" tIns="0" rIns="0" bIns="0" rtlCol="0" anchor="ctr"/>
-          <a:lstStyle/>
-          <a:p>
-            <a:pPr algn="ctr" indent="0" marL="0">
-              <a:buNone/>
-            </a:pPr>
-            <a:r>
-              <a:rPr lang="en-US" sz="1100" dirty="0">
-                <a:solidFill>
-                  <a:schemeClr val="tx1"/>
-                </a:solidFill>
-              </a:rPr>
-              <a:t>TheLoai</a:t>
-            </a:r>
-            <a:endParaRPr lang="en-US" sz="1100" dirty="0"/>
-          </a:p>
-        </p:txBody>
-      </p:sp>
-      <p:sp>
-        <p:nvSpPr>
-          <p:cNvPr id="42" name="Attr PHIM ThoiLuong"/>
-          <p:cNvSpPr/>
-          <p:nvPr/>
-        </p:nvSpPr>
-        <p:spPr>
-          <a:xfrm>
-            <a:off x="297180" y="3557016"/>
-            <a:ext cx="1325880" cy="384048"/>
-          </a:xfrm>
-          <a:prstGeom prst="ellipse">
-            <a:avLst/>
-          </a:prstGeom>
-          <a:solidFill>
-            <a:schemeClr val="bg1"/>
-          </a:solidFill>
-          <a:ln w="12700">
-            <a:solidFill>
-              <a:schemeClr val="tx2"/>
-            </a:solidFill>
-          </a:ln>
-        </p:spPr>
-        <p:txBody>
-          <a:bodyPr wrap="square" lIns="0" tIns="0" rIns="0" bIns="0" rtlCol="0" anchor="ctr"/>
-          <a:lstStyle/>
-          <a:p>
-            <a:pPr algn="ctr" indent="0" marL="0">
-              <a:buNone/>
-            </a:pPr>
-            <a:r>
-              <a:rPr lang="en-US" sz="1100" dirty="0">
-                <a:solidFill>
-                  <a:schemeClr val="tx1"/>
-                </a:solidFill>
-              </a:rPr>
-              <a:t>ThoiLuong</a:t>
-            </a:r>
-            <a:endParaRPr lang="en-US" sz="1100" dirty="0"/>
-          </a:p>
-        </p:txBody>
-      </p:sp>
-      <p:sp>
-        <p:nvSpPr>
-          <p:cNvPr id="43" name="Attr PHIM NgayKhoiChieu"/>
-          <p:cNvSpPr/>
-          <p:nvPr/>
-        </p:nvSpPr>
-        <p:spPr>
-          <a:xfrm>
-            <a:off x="1805940" y="3557016"/>
-            <a:ext cx="1325880" cy="384048"/>
-          </a:xfrm>
-          <a:prstGeom prst="ellipse">
-            <a:avLst/>
-          </a:prstGeom>
-          <a:solidFill>
-            <a:schemeClr val="bg1"/>
-          </a:solidFill>
-          <a:ln w="12700">
-            <a:solidFill>
-              <a:schemeClr val="tx2"/>
-            </a:solidFill>
-          </a:ln>
-        </p:spPr>
-        <p:txBody>
-          <a:bodyPr wrap="square" lIns="0" tIns="0" rIns="0" bIns="0" rtlCol="0" anchor="ctr"/>
-          <a:lstStyle/>
-          <a:p>
-            <a:pPr algn="ctr" indent="0" marL="0">
-              <a:buNone/>
-            </a:pPr>
-            <a:r>
-              <a:rPr lang="en-US" sz="1100" dirty="0">
-                <a:solidFill>
-                  <a:schemeClr val="tx1"/>
-                </a:solidFill>
-              </a:rPr>
-              <a:t>NgayKhoiChieu</a:t>
-            </a:r>
-            <a:endParaRPr lang="en-US" sz="1100" dirty="0"/>
-          </a:p>
-        </p:txBody>
-      </p:sp>
-      <p:sp>
-        <p:nvSpPr>
-          <p:cNvPr id="44" name="Attr PHONGCHIEU MaPhong"/>
-          <p:cNvSpPr/>
-          <p:nvPr/>
-        </p:nvSpPr>
-        <p:spPr>
-          <a:xfrm>
-            <a:off x="9029700" y="1362456"/>
-            <a:ext cx="1325880" cy="384048"/>
-          </a:xfrm>
-          <a:prstGeom prst="ellipse">
-            <a:avLst/>
-          </a:prstGeom>
-          <a:solidFill>
-            <a:schemeClr val="bg1"/>
-          </a:solidFill>
-          <a:ln w="12700">
-            <a:solidFill>
-              <a:schemeClr val="tx2"/>
-            </a:solidFill>
-          </a:ln>
-        </p:spPr>
-        <p:txBody>
-          <a:bodyPr wrap="square" lIns="0" tIns="0" rIns="0" bIns="0" rtlCol="0" anchor="ctr"/>
-          <a:lstStyle/>
-          <a:p>
-            <a:pPr algn="ctr" indent="0" marL="0">
-              <a:buNone/>
-            </a:pPr>
-            <a:r>
-              <a:rPr lang="en-US" sz="1100" b="1" u="sng" dirty="0">
-                <a:solidFill>
-                  <a:schemeClr val="tx1"/>
-                </a:solidFill>
-              </a:rPr>
-              <a:t>MaPhong</a:t>
-            </a:r>
-            <a:endParaRPr lang="en-US" sz="1100" dirty="0"/>
-          </a:p>
-        </p:txBody>
-      </p:sp>
-      <p:sp>
-        <p:nvSpPr>
-          <p:cNvPr id="45" name="Attr PHONGCHIEU TenPhong"/>
-          <p:cNvSpPr/>
-          <p:nvPr/>
-        </p:nvSpPr>
-        <p:spPr>
-          <a:xfrm>
-            <a:off x="10492740" y="1362456"/>
-            <a:ext cx="1325880" cy="384048"/>
-          </a:xfrm>
-          <a:prstGeom prst="ellipse">
-            <a:avLst/>
-          </a:prstGeom>
-          <a:solidFill>
-            <a:schemeClr val="bg1"/>
-          </a:solidFill>
-          <a:ln w="12700">
-            <a:solidFill>
-              <a:schemeClr val="tx2"/>
-            </a:solidFill>
-          </a:ln>
-        </p:spPr>
-        <p:txBody>
-          <a:bodyPr wrap="square" lIns="0" tIns="0" rIns="0" bIns="0" rtlCol="0" anchor="ctr"/>
-          <a:lstStyle/>
-          <a:p>
-            <a:pPr algn="ctr" indent="0" marL="0">
-              <a:buNone/>
-            </a:pPr>
-            <a:r>
-              <a:rPr lang="en-US" sz="1100" dirty="0">
-                <a:solidFill>
-                  <a:schemeClr val="tx1"/>
-                </a:solidFill>
-              </a:rPr>
-              <a:t>TenPhong</a:t>
-            </a:r>
-            <a:endParaRPr lang="en-US" sz="1100" dirty="0"/>
-          </a:p>
-        </p:txBody>
-      </p:sp>
-      <p:sp>
-        <p:nvSpPr>
-          <p:cNvPr id="46" name="Attr PHONGCHIEU LoaiPhong"/>
-          <p:cNvSpPr/>
-          <p:nvPr/>
-        </p:nvSpPr>
-        <p:spPr>
-          <a:xfrm>
-            <a:off x="9029700" y="3557016"/>
-            <a:ext cx="1325880" cy="384048"/>
-          </a:xfrm>
-          <a:prstGeom prst="ellipse">
-            <a:avLst/>
-          </a:prstGeom>
-          <a:solidFill>
-            <a:schemeClr val="bg1"/>
-          </a:solidFill>
-          <a:ln w="12700">
-            <a:solidFill>
-              <a:schemeClr val="tx2"/>
-            </a:solidFill>
-          </a:ln>
-        </p:spPr>
-        <p:txBody>
-          <a:bodyPr wrap="square" lIns="0" tIns="0" rIns="0" bIns="0" rtlCol="0" anchor="ctr"/>
-          <a:lstStyle/>
-          <a:p>
-            <a:pPr algn="ctr" indent="0" marL="0">
-              <a:buNone/>
-            </a:pPr>
-            <a:r>
-              <a:rPr lang="en-US" sz="1100" dirty="0">
-                <a:solidFill>
-                  <a:schemeClr val="tx1"/>
-                </a:solidFill>
-              </a:rPr>
-              <a:t>LoaiPhong</a:t>
-            </a:r>
-            <a:endParaRPr lang="en-US" sz="1100" dirty="0"/>
-          </a:p>
-        </p:txBody>
-      </p:sp>
-      <p:sp>
-        <p:nvSpPr>
-          <p:cNvPr id="47" name="Attr PHONGCHIEU SucChua"/>
-          <p:cNvSpPr/>
-          <p:nvPr/>
-        </p:nvSpPr>
-        <p:spPr>
-          <a:xfrm>
-            <a:off x="10492740" y="3557016"/>
-            <a:ext cx="1325880" cy="384048"/>
-          </a:xfrm>
-          <a:prstGeom prst="ellipse">
-            <a:avLst/>
-          </a:prstGeom>
-          <a:solidFill>
-            <a:schemeClr val="bg1"/>
-          </a:solidFill>
-          <a:ln w="12700">
-            <a:solidFill>
-              <a:schemeClr val="tx2"/>
-            </a:solidFill>
-          </a:ln>
-        </p:spPr>
-        <p:txBody>
-          <a:bodyPr wrap="square" lIns="0" tIns="0" rIns="0" bIns="0" rtlCol="0" anchor="ctr"/>
-          <a:lstStyle/>
-          <a:p>
-            <a:pPr algn="ctr" indent="0" marL="0">
-              <a:buNone/>
-            </a:pPr>
-            <a:r>
-              <a:rPr lang="en-US" sz="1100" dirty="0">
-                <a:solidFill>
-                  <a:schemeClr val="tx1"/>
-                </a:solidFill>
-              </a:rPr>
-              <a:t>SucChua</a:t>
-            </a:r>
-            <a:endParaRPr lang="en-US" sz="1100" dirty="0"/>
-          </a:p>
-        </p:txBody>
-      </p:sp>
-      <p:sp>
-        <p:nvSpPr>
-          <p:cNvPr id="48" name="Attr SUATCHIEU MaSuat"/>
-          <p:cNvSpPr/>
-          <p:nvPr/>
-        </p:nvSpPr>
-        <p:spPr>
-          <a:xfrm>
-            <a:off x="4686300" y="1362456"/>
-            <a:ext cx="1325880" cy="384048"/>
-          </a:xfrm>
-          <a:prstGeom prst="ellipse">
-            <a:avLst/>
-          </a:prstGeom>
-          <a:solidFill>
-            <a:schemeClr val="bg1"/>
-          </a:solidFill>
-          <a:ln w="12700">
-            <a:solidFill>
-              <a:schemeClr val="tx2"/>
-            </a:solidFill>
-          </a:ln>
-        </p:spPr>
-        <p:txBody>
-          <a:bodyPr wrap="square" lIns="0" tIns="0" rIns="0" bIns="0" rtlCol="0" anchor="ctr"/>
-          <a:lstStyle/>
-          <a:p>
-            <a:pPr algn="ctr" indent="0" marL="0">
-              <a:buNone/>
-            </a:pPr>
-            <a:r>
-              <a:rPr lang="en-US" sz="1100" b="1" u="sng" dirty="0">
-                <a:solidFill>
-                  <a:schemeClr val="tx1"/>
-                </a:solidFill>
-              </a:rPr>
-              <a:t>MaSuat</a:t>
-            </a:r>
-            <a:endParaRPr lang="en-US" sz="1100" dirty="0"/>
-          </a:p>
-        </p:txBody>
-      </p:sp>
-      <p:sp>
-        <p:nvSpPr>
-          <p:cNvPr id="49" name="Attr SUATCHIEU NgayChieu"/>
-          <p:cNvSpPr/>
-          <p:nvPr/>
-        </p:nvSpPr>
-        <p:spPr>
-          <a:xfrm>
-            <a:off x="6149340" y="1362456"/>
-            <a:ext cx="1325880" cy="384048"/>
-          </a:xfrm>
-          <a:prstGeom prst="ellipse">
-            <a:avLst/>
-          </a:prstGeom>
-          <a:solidFill>
-            <a:schemeClr val="bg1"/>
-          </a:solidFill>
-          <a:ln w="12700">
-            <a:solidFill>
-              <a:schemeClr val="tx2"/>
-            </a:solidFill>
-          </a:ln>
-        </p:spPr>
-        <p:txBody>
-          <a:bodyPr wrap="square" lIns="0" tIns="0" rIns="0" bIns="0" rtlCol="0" anchor="ctr"/>
-          <a:lstStyle/>
-          <a:p>
-            <a:pPr algn="ctr" indent="0" marL="0">
-              <a:buNone/>
-            </a:pPr>
-            <a:r>
-              <a:rPr lang="en-US" sz="1100" dirty="0">
-                <a:solidFill>
-                  <a:schemeClr val="tx1"/>
-                </a:solidFill>
-              </a:rPr>
-              <a:t>NgayChieu</a:t>
-            </a:r>
-            <a:endParaRPr lang="en-US" sz="1100" dirty="0"/>
-          </a:p>
-        </p:txBody>
-      </p:sp>
-      <p:sp>
-        <p:nvSpPr>
-          <p:cNvPr id="50" name="Attr SUATCHIEU GioBatDau"/>
-          <p:cNvSpPr/>
-          <p:nvPr/>
-        </p:nvSpPr>
-        <p:spPr>
-          <a:xfrm>
-            <a:off x="4046220" y="3511296"/>
-            <a:ext cx="1325880" cy="384048"/>
-          </a:xfrm>
-          <a:prstGeom prst="ellipse">
-            <a:avLst/>
-          </a:prstGeom>
-          <a:solidFill>
-            <a:schemeClr val="bg1"/>
-          </a:solidFill>
-          <a:ln w="12700">
-            <a:solidFill>
-              <a:schemeClr val="tx2"/>
-            </a:solidFill>
-          </a:ln>
-        </p:spPr>
-        <p:txBody>
-          <a:bodyPr wrap="square" lIns="0" tIns="0" rIns="0" bIns="0" rtlCol="0" anchor="ctr"/>
-          <a:lstStyle/>
-          <a:p>
-            <a:pPr algn="ctr" indent="0" marL="0">
-              <a:buNone/>
-            </a:pPr>
-            <a:r>
-              <a:rPr lang="en-US" sz="1100" dirty="0">
-                <a:solidFill>
-                  <a:schemeClr val="tx1"/>
-                </a:solidFill>
-              </a:rPr>
-              <a:t>GioBatDau</a:t>
-            </a:r>
-            <a:endParaRPr lang="en-US" sz="1100" dirty="0"/>
-          </a:p>
-        </p:txBody>
-      </p:sp>
-      <p:sp>
-        <p:nvSpPr>
-          <p:cNvPr id="51" name="Attr SUATCHIEU GiaVe"/>
-          <p:cNvSpPr/>
-          <p:nvPr/>
-        </p:nvSpPr>
-        <p:spPr>
-          <a:xfrm>
-            <a:off x="6835140" y="3511296"/>
-            <a:ext cx="1325880" cy="384048"/>
-          </a:xfrm>
-          <a:prstGeom prst="ellipse">
-            <a:avLst/>
-          </a:prstGeom>
-          <a:solidFill>
-            <a:schemeClr val="bg1"/>
-          </a:solidFill>
-          <a:ln w="12700">
-            <a:solidFill>
-              <a:schemeClr val="tx2"/>
-            </a:solidFill>
-          </a:ln>
-        </p:spPr>
-        <p:txBody>
-          <a:bodyPr wrap="square" lIns="0" tIns="0" rIns="0" bIns="0" rtlCol="0" anchor="ctr"/>
-          <a:lstStyle/>
-          <a:p>
-            <a:pPr algn="ctr" indent="0" marL="0">
-              <a:buNone/>
-            </a:pPr>
-            <a:r>
-              <a:rPr lang="en-US" sz="1100" dirty="0">
-                <a:solidFill>
-                  <a:schemeClr val="tx1"/>
-                </a:solidFill>
-              </a:rPr>
-              <a:t>GiaVe</a:t>
-            </a:r>
-            <a:endParaRPr lang="en-US" sz="1100" dirty="0"/>
-          </a:p>
-        </p:txBody>
-      </p:sp>
-      <p:sp>
-        <p:nvSpPr>
-          <p:cNvPr id="52" name="Attr KHACHHANG MaKH"/>
-          <p:cNvSpPr/>
-          <p:nvPr/>
-        </p:nvSpPr>
-        <p:spPr>
-          <a:xfrm>
-            <a:off x="114300" y="5934456"/>
-            <a:ext cx="1325880" cy="384048"/>
-          </a:xfrm>
-          <a:prstGeom prst="ellipse">
-            <a:avLst/>
-          </a:prstGeom>
-          <a:solidFill>
-            <a:schemeClr val="bg1"/>
-          </a:solidFill>
-          <a:ln w="12700">
-            <a:solidFill>
-              <a:schemeClr val="tx2"/>
-            </a:solidFill>
-          </a:ln>
-        </p:spPr>
-        <p:txBody>
-          <a:bodyPr wrap="square" lIns="0" tIns="0" rIns="0" bIns="0" rtlCol="0" anchor="ctr"/>
-          <a:lstStyle/>
-          <a:p>
-            <a:pPr algn="ctr" indent="0" marL="0">
-              <a:buNone/>
-            </a:pPr>
-            <a:r>
-              <a:rPr lang="en-US" sz="1100" b="1" u="sng" dirty="0">
-                <a:solidFill>
-                  <a:schemeClr val="tx1"/>
-                </a:solidFill>
-              </a:rPr>
-              <a:t>MaKH</a:t>
-            </a:r>
-            <a:endParaRPr lang="en-US" sz="1100" dirty="0"/>
-          </a:p>
-        </p:txBody>
-      </p:sp>
-      <p:sp>
-        <p:nvSpPr>
-          <p:cNvPr id="53" name="Attr KHACHHANG HoTen"/>
-          <p:cNvSpPr/>
-          <p:nvPr/>
-        </p:nvSpPr>
-        <p:spPr>
-          <a:xfrm>
-            <a:off x="1485900" y="5934456"/>
-            <a:ext cx="1325880" cy="384048"/>
-          </a:xfrm>
-          <a:prstGeom prst="ellipse">
-            <a:avLst/>
-          </a:prstGeom>
-          <a:solidFill>
-            <a:schemeClr val="bg1"/>
-          </a:solidFill>
-          <a:ln w="12700">
-            <a:solidFill>
-              <a:schemeClr val="tx2"/>
-            </a:solidFill>
-          </a:ln>
-        </p:spPr>
-        <p:txBody>
-          <a:bodyPr wrap="square" lIns="0" tIns="0" rIns="0" bIns="0" rtlCol="0" anchor="ctr"/>
-          <a:lstStyle/>
-          <a:p>
-            <a:pPr algn="ctr" indent="0" marL="0">
-              <a:buNone/>
-            </a:pPr>
-            <a:r>
-              <a:rPr lang="en-US" sz="1100" dirty="0">
-                <a:solidFill>
-                  <a:schemeClr val="tx1"/>
-                </a:solidFill>
-              </a:rPr>
-              <a:t>HoTen</a:t>
-            </a:r>
-            <a:endParaRPr lang="en-US" sz="1100" dirty="0"/>
-          </a:p>
-        </p:txBody>
-      </p:sp>
-      <p:sp>
-        <p:nvSpPr>
-          <p:cNvPr id="54" name="Attr KHACHHANG SDT"/>
-          <p:cNvSpPr/>
-          <p:nvPr/>
-        </p:nvSpPr>
-        <p:spPr>
-          <a:xfrm>
-            <a:off x="2811780" y="5934456"/>
-            <a:ext cx="1325880" cy="384048"/>
-          </a:xfrm>
-          <a:prstGeom prst="ellipse">
-            <a:avLst/>
-          </a:prstGeom>
-          <a:solidFill>
-            <a:schemeClr val="bg1"/>
-          </a:solidFill>
-          <a:ln w="12700">
-            <a:solidFill>
-              <a:schemeClr val="tx2"/>
-            </a:solidFill>
-          </a:ln>
-        </p:spPr>
-        <p:txBody>
-          <a:bodyPr wrap="square" lIns="0" tIns="0" rIns="0" bIns="0" rtlCol="0" anchor="ctr"/>
-          <a:lstStyle/>
-          <a:p>
-            <a:pPr algn="ctr" indent="0" marL="0">
-              <a:buNone/>
-            </a:pPr>
-            <a:r>
-              <a:rPr lang="en-US" sz="1100" dirty="0">
-                <a:solidFill>
-                  <a:schemeClr val="tx1"/>
-                </a:solidFill>
-              </a:rPr>
-              <a:t>SDT</a:t>
-            </a:r>
-            <a:endParaRPr lang="en-US" sz="1100" dirty="0"/>
-          </a:p>
-        </p:txBody>
-      </p:sp>
-      <p:sp>
-        <p:nvSpPr>
-          <p:cNvPr id="55" name="Attr KHACHHANG Email"/>
-          <p:cNvSpPr/>
-          <p:nvPr/>
-        </p:nvSpPr>
-        <p:spPr>
-          <a:xfrm>
-            <a:off x="68580" y="4242816"/>
-            <a:ext cx="1325880" cy="384048"/>
-          </a:xfrm>
-          <a:prstGeom prst="ellipse">
-            <a:avLst/>
-          </a:prstGeom>
-          <a:solidFill>
-            <a:schemeClr val="bg1"/>
-          </a:solidFill>
-          <a:ln w="12700">
-            <a:solidFill>
-              <a:schemeClr val="tx2"/>
-            </a:solidFill>
-          </a:ln>
-        </p:spPr>
-        <p:txBody>
-          <a:bodyPr wrap="square" lIns="0" tIns="0" rIns="0" bIns="0" rtlCol="0" anchor="ctr"/>
-          <a:lstStyle/>
-          <a:p>
-            <a:pPr algn="ctr" indent="0" marL="0">
-              <a:buNone/>
-            </a:pPr>
-            <a:r>
-              <a:rPr lang="en-US" sz="1100" dirty="0">
-                <a:solidFill>
-                  <a:schemeClr val="tx1"/>
-                </a:solidFill>
-              </a:rPr>
-              <a:t>Email</a:t>
-            </a:r>
-            <a:endParaRPr lang="en-US" sz="1100" dirty="0"/>
-          </a:p>
-        </p:txBody>
-      </p:sp>
-      <p:sp>
-        <p:nvSpPr>
-          <p:cNvPr id="56" name="Attr VE SoGhe"/>
-          <p:cNvSpPr/>
-          <p:nvPr/>
-        </p:nvSpPr>
-        <p:spPr>
-          <a:xfrm>
-            <a:off x="4823460" y="5934456"/>
-            <a:ext cx="1325880" cy="384048"/>
-          </a:xfrm>
-          <a:prstGeom prst="ellipse">
-            <a:avLst/>
-          </a:prstGeom>
-          <a:solidFill>
-            <a:schemeClr val="bg1"/>
-          </a:solidFill>
-          <a:ln w="12700">
-            <a:solidFill>
-              <a:schemeClr val="tx2"/>
-            </a:solidFill>
-          </a:ln>
-        </p:spPr>
-        <p:txBody>
-          <a:bodyPr wrap="square" lIns="0" tIns="0" rIns="0" bIns="0" rtlCol="0" anchor="ctr"/>
-          <a:lstStyle/>
-          <a:p>
-            <a:pPr algn="ctr" indent="0" marL="0">
-              <a:buNone/>
-            </a:pPr>
-            <a:r>
-              <a:rPr lang="en-US" sz="1100" b="1" u="dash" dirty="0">
-                <a:solidFill>
-                  <a:schemeClr val="tx1"/>
-                </a:solidFill>
-              </a:rPr>
-              <a:t>SoGhe</a:t>
-            </a:r>
-            <a:endParaRPr lang="en-US" sz="1100" dirty="0"/>
-          </a:p>
-        </p:txBody>
-      </p:sp>
-      <p:sp>
-        <p:nvSpPr>
-          <p:cNvPr id="57" name="Attr VE NgayDat"/>
-          <p:cNvSpPr/>
-          <p:nvPr/>
-        </p:nvSpPr>
-        <p:spPr>
-          <a:xfrm>
-            <a:off x="6195060" y="5934456"/>
-            <a:ext cx="1325880" cy="384048"/>
-          </a:xfrm>
-          <a:prstGeom prst="ellipse">
-            <a:avLst/>
-          </a:prstGeom>
-          <a:solidFill>
-            <a:schemeClr val="bg1"/>
-          </a:solidFill>
-          <a:ln w="12700">
-            <a:solidFill>
-              <a:schemeClr val="tx2"/>
-            </a:solidFill>
-          </a:ln>
-        </p:spPr>
-        <p:txBody>
-          <a:bodyPr wrap="square" lIns="0" tIns="0" rIns="0" bIns="0" rtlCol="0" anchor="ctr"/>
-          <a:lstStyle/>
-          <a:p>
-            <a:pPr algn="ctr" indent="0" marL="0">
-              <a:buNone/>
-            </a:pPr>
-            <a:r>
-              <a:rPr lang="en-US" sz="1100" dirty="0">
-                <a:solidFill>
-                  <a:schemeClr val="tx1"/>
-                </a:solidFill>
-              </a:rPr>
-              <a:t>NgayDat</a:t>
-            </a:r>
-            <a:endParaRPr lang="en-US" sz="1100" dirty="0"/>
-          </a:p>
-        </p:txBody>
-      </p:sp>
-      <p:sp>
-        <p:nvSpPr>
-          <p:cNvPr id="58" name="Relationship PHIM-SUATCHIEU"/>
-          <p:cNvSpPr/>
-          <p:nvPr/>
-        </p:nvSpPr>
-        <p:spPr>
-          <a:xfrm>
-            <a:off x="3364992" y="2423160"/>
-            <a:ext cx="1097280" cy="640080"/>
-          </a:xfrm>
-          <a:prstGeom prst="diamond">
-            <a:avLst/>
-          </a:prstGeom>
-          <a:solidFill>
-            <a:schemeClr val="bg2"/>
-          </a:solidFill>
-          <a:ln w="19050">
-            <a:solidFill>
-              <a:schemeClr val="tx1"/>
-            </a:solidFill>
-          </a:ln>
-        </p:spPr>
-        <p:txBody>
-          <a:bodyPr wrap="square" lIns="0" tIns="0" rIns="0" bIns="0" rtlCol="0" anchor="ctr"/>
-          <a:lstStyle/>
-          <a:p>
-            <a:pPr algn="ctr" indent="0" marL="0">
-              <a:buNone/>
-            </a:pPr>
-            <a:r>
-              <a:rPr lang="en-US" sz="1300" b="1" dirty="0">
-                <a:solidFill>
-                  <a:schemeClr val="tx1"/>
-                </a:solidFill>
-              </a:rPr>
-              <a:t>chiếu</a:t>
-            </a:r>
-            <a:endParaRPr lang="en-US" sz="1300" dirty="0"/>
-          </a:p>
-        </p:txBody>
-      </p:sp>
-      <p:sp>
-        <p:nvSpPr>
-          <p:cNvPr id="59" name="Relationship PHONGCHIEU-SUATCHIEU"/>
-          <p:cNvSpPr/>
-          <p:nvPr/>
-        </p:nvSpPr>
-        <p:spPr>
-          <a:xfrm>
-            <a:off x="7726680" y="2423160"/>
-            <a:ext cx="1097280" cy="640080"/>
-          </a:xfrm>
-          <a:prstGeom prst="diamond">
-            <a:avLst/>
-          </a:prstGeom>
-          <a:solidFill>
-            <a:schemeClr val="bg2"/>
-          </a:solidFill>
-          <a:ln w="19050">
-            <a:solidFill>
-              <a:schemeClr val="tx1"/>
-            </a:solidFill>
-          </a:ln>
-        </p:spPr>
-        <p:txBody>
-          <a:bodyPr wrap="square" lIns="0" tIns="0" rIns="0" bIns="0" rtlCol="0" anchor="ctr"/>
-          <a:lstStyle/>
-          <a:p>
-            <a:pPr algn="ctr" indent="0" marL="0">
-              <a:buNone/>
-            </a:pPr>
-            <a:r>
-              <a:rPr lang="en-US" sz="1300" b="1" dirty="0">
-                <a:solidFill>
-                  <a:schemeClr val="tx1"/>
-                </a:solidFill>
-              </a:rPr>
-              <a:t>tại</a:t>
-            </a:r>
-            <a:endParaRPr lang="en-US" sz="1300" dirty="0"/>
-          </a:p>
-        </p:txBody>
-      </p:sp>
-      <p:sp>
-        <p:nvSpPr>
-          <p:cNvPr id="60" name="Relationship outer SUATCHIEU-VE"/>
-          <p:cNvSpPr/>
-          <p:nvPr/>
-        </p:nvSpPr>
-        <p:spPr>
-          <a:xfrm>
-            <a:off x="5550408" y="3657600"/>
-            <a:ext cx="1097280" cy="640080"/>
-          </a:xfrm>
-          <a:prstGeom prst="diamond">
-            <a:avLst/>
-          </a:prstGeom>
-          <a:solidFill>
-            <a:schemeClr val="bg2"/>
-          </a:solidFill>
-          <a:ln w="19050">
-            <a:solidFill>
-              <a:schemeClr val="tx1"/>
-            </a:solidFill>
-            <a:prstDash val="solid"/>
-          </a:ln>
-        </p:spPr>
-      </p:sp>
-      <p:sp>
-        <p:nvSpPr>
-          <p:cNvPr id="61" name="Relationship SUATCHIEU-VE"/>
-          <p:cNvSpPr/>
-          <p:nvPr/>
-        </p:nvSpPr>
-        <p:spPr>
-          <a:xfrm>
-            <a:off x="5682082" y="3734410"/>
-            <a:ext cx="833933" cy="486461"/>
-          </a:xfrm>
-          <a:prstGeom prst="diamond">
-            <a:avLst/>
-          </a:prstGeom>
-          <a:solidFill>
-            <a:schemeClr val="bg2"/>
-          </a:solidFill>
-          <a:ln w="19050">
-            <a:solidFill>
-              <a:schemeClr val="tx1"/>
-            </a:solidFill>
-          </a:ln>
-        </p:spPr>
-        <p:txBody>
-          <a:bodyPr wrap="square" lIns="0" tIns="0" rIns="0" bIns="0" rtlCol="0" anchor="ctr"/>
-          <a:lstStyle/>
-          <a:p>
-            <a:pPr algn="ctr" indent="0" marL="0">
-              <a:buNone/>
-            </a:pPr>
-            <a:r>
-              <a:rPr lang="en-US" sz="1300" b="1" dirty="0">
-                <a:solidFill>
-                  <a:schemeClr val="tx1"/>
-                </a:solidFill>
-              </a:rPr>
-              <a:t>bán</a:t>
-            </a:r>
-            <a:endParaRPr lang="en-US" sz="1300" dirty="0"/>
-          </a:p>
-        </p:txBody>
-      </p:sp>
-      <p:sp>
-        <p:nvSpPr>
-          <p:cNvPr id="62" name="Relationship KHACHHANG-VE"/>
-          <p:cNvSpPr/>
-          <p:nvPr/>
-        </p:nvSpPr>
-        <p:spPr>
-          <a:xfrm>
-            <a:off x="3364992" y="4892040"/>
-            <a:ext cx="1097280" cy="640080"/>
-          </a:xfrm>
-          <a:prstGeom prst="diamond">
-            <a:avLst/>
-          </a:prstGeom>
-          <a:solidFill>
-            <a:schemeClr val="bg2"/>
-          </a:solidFill>
-          <a:ln w="19050">
-            <a:solidFill>
-              <a:schemeClr val="tx1"/>
-            </a:solidFill>
-          </a:ln>
-        </p:spPr>
-        <p:txBody>
-          <a:bodyPr wrap="square" lIns="0" tIns="0" rIns="0" bIns="0" rtlCol="0" anchor="ctr"/>
-          <a:lstStyle/>
-          <a:p>
-            <a:pPr algn="ctr" indent="0" marL="0">
-              <a:buNone/>
-            </a:pPr>
-            <a:r>
-              <a:rPr lang="en-US" sz="1300" b="1" dirty="0">
-                <a:solidFill>
-                  <a:schemeClr val="tx1"/>
-                </a:solidFill>
-              </a:rPr>
-              <a:t>đặt</a:t>
-            </a:r>
-            <a:endParaRPr lang="en-US" sz="1300" dirty="0"/>
-          </a:p>
-        </p:txBody>
-      </p:sp>
-      <p:sp>
-        <p:nvSpPr>
-          <p:cNvPr id="63" name="Entity PHIM"/>
-          <p:cNvSpPr/>
-          <p:nvPr/>
-        </p:nvSpPr>
-        <p:spPr>
-          <a:xfrm>
-            <a:off x="937260" y="2491740"/>
-            <a:ext cx="1600200" cy="502920"/>
-          </a:xfrm>
-          <a:prstGeom prst="rect">
-            <a:avLst/>
-          </a:prstGeom>
-          <a:solidFill>
-            <a:schemeClr val="tx1"/>
-          </a:solidFill>
-          <a:ln w="19050">
-            <a:solidFill>
-              <a:schemeClr val="tx1"/>
-            </a:solidFill>
-          </a:ln>
-        </p:spPr>
-        <p:txBody>
-          <a:bodyPr wrap="square" lIns="0" tIns="0" rIns="0" bIns="0" rtlCol="0" anchor="ctr"/>
-          <a:lstStyle/>
-          <a:p>
-            <a:pPr algn="ctr" indent="0" marL="0">
-              <a:buNone/>
-            </a:pPr>
-            <a:r>
-              <a:rPr lang="en-US" sz="1300" b="1" dirty="0">
-                <a:solidFill>
-                  <a:schemeClr val="bg1"/>
-                </a:solidFill>
-              </a:rPr>
-              <a:t>PHIM</a:t>
-            </a:r>
-            <a:endParaRPr lang="en-US" sz="1300" dirty="0"/>
-          </a:p>
-        </p:txBody>
-      </p:sp>
-      <p:sp>
-        <p:nvSpPr>
-          <p:cNvPr id="64" name="Entity PHONGCHIEU"/>
-          <p:cNvSpPr/>
-          <p:nvPr/>
-        </p:nvSpPr>
-        <p:spPr>
-          <a:xfrm>
-            <a:off x="9624060" y="2491740"/>
-            <a:ext cx="1600200" cy="502920"/>
-          </a:xfrm>
-          <a:prstGeom prst="rect">
-            <a:avLst/>
-          </a:prstGeom>
-          <a:solidFill>
-            <a:schemeClr val="tx1"/>
-          </a:solidFill>
-          <a:ln w="19050">
-            <a:solidFill>
-              <a:schemeClr val="tx1"/>
-            </a:solidFill>
-          </a:ln>
-        </p:spPr>
-        <p:txBody>
-          <a:bodyPr wrap="square" lIns="0" tIns="0" rIns="0" bIns="0" rtlCol="0" anchor="ctr"/>
-          <a:lstStyle/>
-          <a:p>
-            <a:pPr algn="ctr" indent="0" marL="0">
-              <a:buNone/>
-            </a:pPr>
-            <a:r>
-              <a:rPr lang="en-US" sz="1300" b="1" dirty="0">
-                <a:solidFill>
-                  <a:schemeClr val="bg1"/>
-                </a:solidFill>
-              </a:rPr>
-              <a:t>PHONGCHIEU</a:t>
-            </a:r>
-            <a:endParaRPr lang="en-US" sz="1300" dirty="0"/>
-          </a:p>
-        </p:txBody>
-      </p:sp>
-      <p:sp>
-        <p:nvSpPr>
-          <p:cNvPr id="65" name="Entity SUATCHIEU"/>
-          <p:cNvSpPr/>
-          <p:nvPr/>
-        </p:nvSpPr>
-        <p:spPr>
-          <a:xfrm>
-            <a:off x="5298948" y="2491740"/>
-            <a:ext cx="1600200" cy="502920"/>
-          </a:xfrm>
-          <a:prstGeom prst="rect">
-            <a:avLst/>
-          </a:prstGeom>
-          <a:solidFill>
-            <a:schemeClr val="accent1"/>
-          </a:solidFill>
-          <a:ln w="19050">
-            <a:solidFill>
-              <a:schemeClr val="tx1"/>
-            </a:solidFill>
-          </a:ln>
-        </p:spPr>
-        <p:txBody>
-          <a:bodyPr wrap="square" lIns="0" tIns="0" rIns="0" bIns="0" rtlCol="0" anchor="ctr"/>
-          <a:lstStyle/>
-          <a:p>
-            <a:pPr algn="ctr" indent="0" marL="0">
-              <a:buNone/>
-            </a:pPr>
-            <a:r>
-              <a:rPr lang="en-US" sz="1300" b="1" dirty="0">
-                <a:solidFill>
-                  <a:schemeClr val="tx1"/>
-                </a:solidFill>
-              </a:rPr>
-              <a:t>SUATCHIEU</a:t>
-            </a:r>
-            <a:endParaRPr lang="en-US" sz="1300" dirty="0"/>
-          </a:p>
-        </p:txBody>
-      </p:sp>
-      <p:sp>
-        <p:nvSpPr>
-          <p:cNvPr id="66" name="Entity KHACHHANG"/>
-          <p:cNvSpPr/>
-          <p:nvPr/>
-        </p:nvSpPr>
-        <p:spPr>
-          <a:xfrm>
-            <a:off x="937260" y="4960620"/>
-            <a:ext cx="1600200" cy="502920"/>
-          </a:xfrm>
-          <a:prstGeom prst="rect">
-            <a:avLst/>
-          </a:prstGeom>
-          <a:solidFill>
-            <a:schemeClr val="tx1"/>
-          </a:solidFill>
-          <a:ln w="19050">
-            <a:solidFill>
-              <a:schemeClr val="tx1"/>
-            </a:solidFill>
-          </a:ln>
-        </p:spPr>
-        <p:txBody>
-          <a:bodyPr wrap="square" lIns="0" tIns="0" rIns="0" bIns="0" rtlCol="0" anchor="ctr"/>
-          <a:lstStyle/>
-          <a:p>
-            <a:pPr algn="ctr" indent="0" marL="0">
-              <a:buNone/>
-            </a:pPr>
-            <a:r>
-              <a:rPr lang="en-US" sz="1300" b="1" dirty="0">
-                <a:solidFill>
-                  <a:schemeClr val="bg1"/>
-                </a:solidFill>
-              </a:rPr>
-              <a:t>KHACHHANG</a:t>
-            </a:r>
-            <a:endParaRPr lang="en-US" sz="1300" dirty="0"/>
-          </a:p>
-        </p:txBody>
-      </p:sp>
-      <p:sp>
-        <p:nvSpPr>
-          <p:cNvPr id="67" name="Entity outer VE"/>
-          <p:cNvSpPr/>
-          <p:nvPr/>
-        </p:nvSpPr>
-        <p:spPr>
-          <a:xfrm>
-            <a:off x="5298948" y="4960620"/>
-            <a:ext cx="1600200" cy="502920"/>
-          </a:xfrm>
-          <a:prstGeom prst="rect">
-            <a:avLst/>
-          </a:prstGeom>
-          <a:solidFill>
-            <a:schemeClr val="bg1"/>
-          </a:solidFill>
-          <a:ln w="19050">
-            <a:solidFill>
-              <a:schemeClr val="tx1"/>
-            </a:solidFill>
-            <a:prstDash val="solid"/>
-          </a:ln>
-        </p:spPr>
-      </p:sp>
-      <p:sp>
-        <p:nvSpPr>
-          <p:cNvPr id="68" name="Entity VE"/>
-          <p:cNvSpPr/>
-          <p:nvPr/>
-        </p:nvSpPr>
-        <p:spPr>
-          <a:xfrm>
-            <a:off x="5362956" y="5024628"/>
-            <a:ext cx="1472184" cy="374904"/>
-          </a:xfrm>
-          <a:prstGeom prst="rect">
-            <a:avLst/>
-          </a:prstGeom>
-          <a:solidFill>
-            <a:schemeClr val="bg2"/>
-          </a:solidFill>
-          <a:ln w="19050">
-            <a:solidFill>
-              <a:schemeClr val="tx1"/>
-            </a:solidFill>
-          </a:ln>
-        </p:spPr>
-        <p:txBody>
-          <a:bodyPr wrap="square" lIns="0" tIns="0" rIns="0" bIns="0" rtlCol="0" anchor="ctr"/>
-          <a:lstStyle/>
-          <a:p>
-            <a:pPr algn="ctr" indent="0" marL="0">
-              <a:buNone/>
-            </a:pPr>
-            <a:r>
-              <a:rPr lang="en-US" sz="1300" b="1" dirty="0">
-                <a:solidFill>
-                  <a:schemeClr val="tx1"/>
-                </a:solidFill>
-              </a:rPr>
-              <a:t>VE</a:t>
-            </a:r>
-            <a:endParaRPr lang="en-US" sz="1300" dirty="0"/>
-          </a:p>
-        </p:txBody>
-      </p:sp>
-      <p:sp>
-        <p:nvSpPr>
-          <p:cNvPr id="69" name="Legend card"/>
-          <p:cNvSpPr/>
-          <p:nvPr/>
-        </p:nvSpPr>
-        <p:spPr>
-          <a:xfrm>
-            <a:off x="8549640" y="4343400"/>
-            <a:ext cx="3182112" cy="2011680"/>
-          </a:xfrm>
-          <a:prstGeom prst="roundRect">
-            <a:avLst>
-              <a:gd name="adj" fmla="val 4545"/>
-            </a:avLst>
-          </a:prstGeom>
-          <a:solidFill>
-            <a:schemeClr val="bg2"/>
-          </a:solidFill>
-          <a:ln w="12700">
-            <a:solidFill>
-              <a:schemeClr val="bg2"/>
-            </a:solidFill>
-            <a:prstDash val="solid"/>
-          </a:ln>
-        </p:spPr>
-      </p:sp>
-      <p:sp>
-        <p:nvSpPr>
-          <p:cNvPr id="70" name="Legend title"/>
-          <p:cNvSpPr txBox="1"/>
-          <p:nvPr/>
-        </p:nvSpPr>
-        <p:spPr>
-          <a:xfrm>
-            <a:off x="8732520" y="4416552"/>
-            <a:ext cx="1828800" cy="256032"/>
-          </a:xfrm>
-          <a:prstGeom prst="rect">
-            <a:avLst/>
-          </a:prstGeom>
-          <a:noFill/>
-          <a:ln/>
-        </p:spPr>
-        <p:txBody>
-          <a:bodyPr wrap="square" lIns="0" tIns="0" rIns="0" bIns="0" rtlCol="0" anchor="t"/>
-          <a:lstStyle/>
-          <a:p>
-            <a:pPr indent="0" marL="0">
-              <a:buNone/>
-            </a:pPr>
-            <a:r>
-              <a:rPr lang="en-US" sz="1200" b="1" dirty="0">
-                <a:solidFill>
-                  <a:schemeClr val="tx1"/>
-                </a:solidFill>
-              </a:rPr>
-              <a:t>Chú thích</a:t>
-            </a:r>
-            <a:endParaRPr lang="en-US" sz="1200" dirty="0"/>
-          </a:p>
-        </p:txBody>
-      </p:sp>
-      <p:sp>
-        <p:nvSpPr>
-          <p:cNvPr id="71" name="Shape 69"/>
-          <p:cNvSpPr/>
-          <p:nvPr/>
-        </p:nvSpPr>
-        <p:spPr>
-          <a:xfrm>
-            <a:off x="8732520" y="4663440"/>
-            <a:ext cx="457200" cy="182880"/>
-          </a:xfrm>
-          <a:prstGeom prst="rect">
-            <a:avLst/>
-          </a:prstGeom>
-          <a:solidFill>
-            <a:schemeClr val="tx1"/>
-          </a:solidFill>
-          <a:ln w="12700">
-            <a:solidFill>
-              <a:schemeClr val="tx1"/>
-            </a:solidFill>
-            <a:prstDash val="solid"/>
-          </a:ln>
-        </p:spPr>
-      </p:sp>
-      <p:sp>
-        <p:nvSpPr>
-          <p:cNvPr id="72" name="Legend 0"/>
-          <p:cNvSpPr txBox="1"/>
-          <p:nvPr/>
-        </p:nvSpPr>
-        <p:spPr>
-          <a:xfrm>
-            <a:off x="9326880" y="4645152"/>
-            <a:ext cx="2313432" cy="219456"/>
-          </a:xfrm>
-          <a:prstGeom prst="rect">
-            <a:avLst/>
-          </a:prstGeom>
-          <a:noFill/>
-          <a:ln/>
-        </p:spPr>
-        <p:txBody>
-          <a:bodyPr wrap="square" lIns="0" tIns="0" rIns="0" bIns="0" rtlCol="0" anchor="ctr"/>
-          <a:lstStyle/>
-          <a:p>
-            <a:pPr indent="0" marL="0">
-              <a:buNone/>
-            </a:pPr>
-            <a:r>
-              <a:rPr lang="en-US" sz="1050" dirty="0">
-                <a:solidFill>
-                  <a:schemeClr val="tx1"/>
-                </a:solidFill>
-              </a:rPr>
-              <a:t>Thực thể</a:t>
-            </a:r>
-            <a:endParaRPr lang="en-US" sz="1050" dirty="0"/>
-          </a:p>
-        </p:txBody>
-      </p:sp>
-      <p:sp>
-        <p:nvSpPr>
-          <p:cNvPr id="73" name="Shape 71"/>
-          <p:cNvSpPr/>
-          <p:nvPr/>
-        </p:nvSpPr>
-        <p:spPr>
-          <a:xfrm>
-            <a:off x="8732520" y="4892040"/>
-            <a:ext cx="457200" cy="182880"/>
-          </a:xfrm>
-          <a:prstGeom prst="rect">
-            <a:avLst/>
-          </a:prstGeom>
-          <a:solidFill>
-            <a:schemeClr val="bg2"/>
-          </a:solidFill>
-          <a:ln w="12700">
-            <a:solidFill>
-              <a:schemeClr val="tx1"/>
-            </a:solidFill>
-            <a:prstDash val="solid"/>
-          </a:ln>
-        </p:spPr>
-      </p:sp>
-      <p:sp>
-        <p:nvSpPr>
-          <p:cNvPr id="74" name="Shape 72"/>
-          <p:cNvSpPr/>
-          <p:nvPr/>
-        </p:nvSpPr>
-        <p:spPr>
-          <a:xfrm>
-            <a:off x="8787384" y="4928616"/>
-            <a:ext cx="347472" cy="109728"/>
-          </a:xfrm>
-          <a:prstGeom prst="rect">
-            <a:avLst/>
-          </a:prstGeom>
-          <a:solidFill>
-            <a:schemeClr val="bg2"/>
-          </a:solidFill>
-          <a:ln w="12700">
-            <a:solidFill>
-              <a:schemeClr val="tx1"/>
-            </a:solidFill>
-            <a:prstDash val="solid"/>
-          </a:ln>
-        </p:spPr>
-      </p:sp>
-      <p:sp>
-        <p:nvSpPr>
-          <p:cNvPr id="75" name="Legend 1"/>
-          <p:cNvSpPr txBox="1"/>
-          <p:nvPr/>
-        </p:nvSpPr>
-        <p:spPr>
-          <a:xfrm>
-            <a:off x="9326880" y="4873752"/>
-            <a:ext cx="2313432" cy="219456"/>
-          </a:xfrm>
-          <a:prstGeom prst="rect">
-            <a:avLst/>
-          </a:prstGeom>
-          <a:noFill/>
-          <a:ln/>
-        </p:spPr>
-        <p:txBody>
-          <a:bodyPr wrap="square" lIns="0" tIns="0" rIns="0" bIns="0" rtlCol="0" anchor="ctr"/>
-          <a:lstStyle/>
-          <a:p>
-            <a:pPr indent="0" marL="0">
-              <a:buNone/>
-            </a:pPr>
-            <a:r>
-              <a:rPr lang="en-US" sz="1050" dirty="0">
-                <a:solidFill>
-                  <a:schemeClr val="tx1"/>
-                </a:solidFill>
-              </a:rPr>
-              <a:t>Thực thể yếu (VE)</a:t>
-            </a:r>
-            <a:endParaRPr lang="en-US" sz="1050" dirty="0"/>
-          </a:p>
-        </p:txBody>
-      </p:sp>
-      <p:sp>
-        <p:nvSpPr>
-          <p:cNvPr id="76" name="Shape 74"/>
-          <p:cNvSpPr/>
-          <p:nvPr/>
-        </p:nvSpPr>
-        <p:spPr>
-          <a:xfrm>
-            <a:off x="8732520" y="5120640"/>
-            <a:ext cx="457200" cy="182880"/>
-          </a:xfrm>
-          <a:prstGeom prst="rect">
-            <a:avLst/>
-          </a:prstGeom>
-          <a:solidFill>
-            <a:schemeClr val="accent1"/>
-          </a:solidFill>
-          <a:ln w="12700">
-            <a:solidFill>
-              <a:schemeClr val="tx1"/>
-            </a:solidFill>
-            <a:prstDash val="solid"/>
-          </a:ln>
-        </p:spPr>
-      </p:sp>
-      <p:sp>
-        <p:nvSpPr>
-          <p:cNvPr id="77" name="Legend 2"/>
-          <p:cNvSpPr txBox="1"/>
-          <p:nvPr/>
-        </p:nvSpPr>
-        <p:spPr>
-          <a:xfrm>
-            <a:off x="9326880" y="5102352"/>
-            <a:ext cx="2313432" cy="219456"/>
-          </a:xfrm>
-          <a:prstGeom prst="rect">
-            <a:avLst/>
-          </a:prstGeom>
-          <a:noFill/>
-          <a:ln/>
-        </p:spPr>
-        <p:txBody>
-          <a:bodyPr wrap="square" lIns="0" tIns="0" rIns="0" bIns="0" rtlCol="0" anchor="ctr"/>
-          <a:lstStyle/>
-          <a:p>
-            <a:pPr indent="0" marL="0">
-              <a:buNone/>
-            </a:pPr>
-            <a:r>
-              <a:rPr lang="en-US" sz="1050" dirty="0">
-                <a:solidFill>
-                  <a:schemeClr val="tx1"/>
-                </a:solidFill>
-              </a:rPr>
-              <a:t>Thực thể kết hợp (quan hệ N – N)</a:t>
-            </a:r>
-            <a:endParaRPr lang="en-US" sz="1050" dirty="0"/>
-          </a:p>
-        </p:txBody>
-      </p:sp>
-      <p:sp>
-        <p:nvSpPr>
-          <p:cNvPr id="78" name="Shape 76"/>
-          <p:cNvSpPr/>
-          <p:nvPr/>
-        </p:nvSpPr>
-        <p:spPr>
-          <a:xfrm>
-            <a:off x="8732520" y="5349240"/>
-            <a:ext cx="457200" cy="182880"/>
-          </a:xfrm>
-          <a:prstGeom prst="diamond">
-            <a:avLst/>
-          </a:prstGeom>
-          <a:solidFill>
-            <a:schemeClr val="bg2"/>
-          </a:solidFill>
-          <a:ln w="12700">
-            <a:solidFill>
-              <a:schemeClr val="tx1"/>
-            </a:solidFill>
-            <a:prstDash val="solid"/>
-          </a:ln>
-        </p:spPr>
-      </p:sp>
-      <p:sp>
-        <p:nvSpPr>
-          <p:cNvPr id="79" name="Legend 3"/>
-          <p:cNvSpPr txBox="1"/>
-          <p:nvPr/>
-        </p:nvSpPr>
-        <p:spPr>
-          <a:xfrm>
-            <a:off x="9326880" y="5330952"/>
-            <a:ext cx="2313432" cy="219456"/>
-          </a:xfrm>
-          <a:prstGeom prst="rect">
-            <a:avLst/>
-          </a:prstGeom>
-          <a:noFill/>
-          <a:ln/>
-        </p:spPr>
-        <p:txBody>
-          <a:bodyPr wrap="square" lIns="0" tIns="0" rIns="0" bIns="0" rtlCol="0" anchor="ctr"/>
-          <a:lstStyle/>
-          <a:p>
-            <a:pPr indent="0" marL="0">
-              <a:buNone/>
-            </a:pPr>
-            <a:r>
-              <a:rPr lang="en-US" sz="1050" dirty="0">
-                <a:solidFill>
-                  <a:schemeClr val="tx1"/>
-                </a:solidFill>
-              </a:rPr>
-              <a:t>Quan hệ</a:t>
-            </a:r>
-            <a:endParaRPr lang="en-US" sz="1050" dirty="0"/>
-          </a:p>
-        </p:txBody>
-      </p:sp>
-      <p:sp>
-        <p:nvSpPr>
-          <p:cNvPr id="80" name="Shape 78"/>
-          <p:cNvSpPr/>
-          <p:nvPr/>
-        </p:nvSpPr>
-        <p:spPr>
-          <a:xfrm>
-            <a:off x="8732520" y="5577840"/>
-            <a:ext cx="457200" cy="182880"/>
-          </a:xfrm>
-          <a:prstGeom prst="diamond">
-            <a:avLst/>
-          </a:prstGeom>
-          <a:solidFill>
-            <a:schemeClr val="bg2"/>
-          </a:solidFill>
-          <a:ln w="12700">
-            <a:solidFill>
-              <a:schemeClr val="tx1"/>
-            </a:solidFill>
-            <a:prstDash val="solid"/>
-          </a:ln>
-        </p:spPr>
-      </p:sp>
-      <p:sp>
-        <p:nvSpPr>
-          <p:cNvPr id="81" name="Shape 79"/>
-          <p:cNvSpPr/>
-          <p:nvPr/>
-        </p:nvSpPr>
-        <p:spPr>
-          <a:xfrm>
-            <a:off x="8787384" y="5614416"/>
-            <a:ext cx="347472" cy="109728"/>
-          </a:xfrm>
-          <a:prstGeom prst="diamond">
-            <a:avLst/>
-          </a:prstGeom>
-          <a:solidFill>
-            <a:schemeClr val="bg2"/>
-          </a:solidFill>
-          <a:ln w="12700">
-            <a:solidFill>
-              <a:schemeClr val="tx1"/>
-            </a:solidFill>
-            <a:prstDash val="solid"/>
-          </a:ln>
-        </p:spPr>
-      </p:sp>
-      <p:sp>
-        <p:nvSpPr>
-          <p:cNvPr id="82" name="Legend 4"/>
-          <p:cNvSpPr txBox="1"/>
-          <p:nvPr/>
-        </p:nvSpPr>
-        <p:spPr>
-          <a:xfrm>
-            <a:off x="9326880" y="5559552"/>
-            <a:ext cx="2313432" cy="219456"/>
-          </a:xfrm>
-          <a:prstGeom prst="rect">
-            <a:avLst/>
-          </a:prstGeom>
-          <a:noFill/>
-          <a:ln/>
-        </p:spPr>
-        <p:txBody>
-          <a:bodyPr wrap="square" lIns="0" tIns="0" rIns="0" bIns="0" rtlCol="0" anchor="ctr"/>
-          <a:lstStyle/>
-          <a:p>
-            <a:pPr indent="0" marL="0">
-              <a:buNone/>
-            </a:pPr>
-            <a:r>
-              <a:rPr lang="en-US" sz="1050" dirty="0">
-                <a:solidFill>
-                  <a:schemeClr val="tx1"/>
-                </a:solidFill>
-              </a:rPr>
-              <a:t>Quan hệ xác định của thực thể yếu</a:t>
-            </a:r>
-            <a:endParaRPr lang="en-US" sz="1050" dirty="0"/>
-          </a:p>
-        </p:txBody>
-      </p:sp>
-      <p:sp>
-        <p:nvSpPr>
-          <p:cNvPr id="83" name="Legend PK sample"/>
-          <p:cNvSpPr txBox="1"/>
-          <p:nvPr/>
-        </p:nvSpPr>
-        <p:spPr>
-          <a:xfrm>
-            <a:off x="8732520" y="5788152"/>
-            <a:ext cx="548640" cy="219456"/>
-          </a:xfrm>
-          <a:prstGeom prst="rect">
-            <a:avLst/>
-          </a:prstGeom>
-          <a:noFill/>
-          <a:ln/>
-        </p:spPr>
-        <p:txBody>
-          <a:bodyPr wrap="square" lIns="0" tIns="0" rIns="0" bIns="0" rtlCol="0" anchor="t"/>
-          <a:lstStyle/>
-          <a:p>
-            <a:pPr indent="0" marL="0">
-              <a:buNone/>
-            </a:pPr>
-            <a:r>
-              <a:rPr lang="en-US" sz="1050" b="1" u="sng" dirty="0">
-                <a:solidFill>
-                  <a:schemeClr val="tx1"/>
-                </a:solidFill>
-              </a:rPr>
-              <a:t>MaXX</a:t>
-            </a:r>
-            <a:endParaRPr lang="en-US" sz="1050" dirty="0"/>
-          </a:p>
-        </p:txBody>
-      </p:sp>
-      <p:sp>
-        <p:nvSpPr>
-          <p:cNvPr id="84" name="Legend 5"/>
-          <p:cNvSpPr txBox="1"/>
-          <p:nvPr/>
-        </p:nvSpPr>
-        <p:spPr>
-          <a:xfrm>
-            <a:off x="9326880" y="5788152"/>
-            <a:ext cx="2313432" cy="219456"/>
-          </a:xfrm>
-          <a:prstGeom prst="rect">
-            <a:avLst/>
-          </a:prstGeom>
-          <a:noFill/>
-          <a:ln/>
-        </p:spPr>
-        <p:txBody>
-          <a:bodyPr wrap="square" lIns="0" tIns="0" rIns="0" bIns="0" rtlCol="0" anchor="ctr"/>
-          <a:lstStyle/>
-          <a:p>
-            <a:pPr indent="0" marL="0">
-              <a:buNone/>
-            </a:pPr>
-            <a:r>
-              <a:rPr lang="en-US" sz="1050" dirty="0">
-                <a:solidFill>
-                  <a:schemeClr val="tx1"/>
-                </a:solidFill>
-              </a:rPr>
-              <a:t>Khóa chính (gạch chân liền)</a:t>
-            </a:r>
-            <a:endParaRPr lang="en-US" sz="1050" dirty="0"/>
-          </a:p>
-        </p:txBody>
-      </p:sp>
-      <p:sp>
-        <p:nvSpPr>
-          <p:cNvPr id="85" name="Legend partial sample"/>
-          <p:cNvSpPr txBox="1"/>
-          <p:nvPr/>
-        </p:nvSpPr>
-        <p:spPr>
-          <a:xfrm>
-            <a:off x="8732520" y="6016752"/>
-            <a:ext cx="548640" cy="219456"/>
-          </a:xfrm>
-          <a:prstGeom prst="rect">
-            <a:avLst/>
-          </a:prstGeom>
-          <a:noFill/>
-          <a:ln/>
-        </p:spPr>
-        <p:txBody>
-          <a:bodyPr wrap="square" lIns="0" tIns="0" rIns="0" bIns="0" rtlCol="0" anchor="t"/>
-          <a:lstStyle/>
-          <a:p>
-            <a:pPr indent="0" marL="0">
-              <a:buNone/>
-            </a:pPr>
-            <a:r>
-              <a:rPr lang="en-US" sz="1050" b="1" u="dash" dirty="0">
-                <a:solidFill>
-                  <a:schemeClr val="tx1"/>
-                </a:solidFill>
-              </a:rPr>
-              <a:t>SoGhe</a:t>
-            </a:r>
-            <a:endParaRPr lang="en-US" sz="1050" dirty="0"/>
-          </a:p>
-        </p:txBody>
-      </p:sp>
-      <p:sp>
-        <p:nvSpPr>
-          <p:cNvPr id="86" name="Legend 6"/>
-          <p:cNvSpPr txBox="1"/>
-          <p:nvPr/>
-        </p:nvSpPr>
-        <p:spPr>
-          <a:xfrm>
-            <a:off x="9326880" y="6016752"/>
-            <a:ext cx="2313432" cy="219456"/>
-          </a:xfrm>
-          <a:prstGeom prst="rect">
-            <a:avLst/>
-          </a:prstGeom>
-          <a:noFill/>
-          <a:ln/>
-        </p:spPr>
-        <p:txBody>
-          <a:bodyPr wrap="square" lIns="0" tIns="0" rIns="0" bIns="0" rtlCol="0" anchor="ctr"/>
-          <a:lstStyle/>
-          <a:p>
-            <a:pPr indent="0" marL="0">
-              <a:buNone/>
-            </a:pPr>
-            <a:r>
-              <a:rPr lang="en-US" sz="1050" dirty="0">
-                <a:solidFill>
-                  <a:schemeClr val="tx1"/>
-                </a:solidFill>
-              </a:rPr>
-              <a:t>Khóa bộ phận (gạch chân đứt)</a:t>
-            </a:r>
-            <a:endParaRPr lang="en-US" sz="1050" dirty="0"/>
-          </a:p>
-        </p:txBody>
-      </p:sp>
+      </p:pic>
       <p:sp>
         <p:nvSpPr>
           <p:cNvPr id="25" name="Slide Number Placeholder 0"/>

</xml_diff>

<commit_message>
Slide 4: black-and-white hand-drawn ER with numbered relationships
Drop colour fills, enlarge labels, number relationships 1-4 in speaking
order and simplify the legend; speaker notes follow the same order.

Co-Authored-By: Claude Opus 5.5 <noreply@anthropic.com>
Claude-Session: https://claude.ai/code/session_01Mv7zheFMCNi8CpghoGk7yL
</commit_message>
<xml_diff>
--- a/hqtcsdl-giuaky/quan_ly_rap_phim.pptx
+++ b/hqtcsdl-giuaky/quan_ly_rap_phim.pptx
@@ -114,26 +114,26 @@
   <p:extLst>
     <p:ext uri="{521415D9-36F7-43E2-AB2F-B90AF26B5E84}">
       <p14:sectionLst xmlns:p14="http://schemas.microsoft.com/office/powerpoint/2010/main">
-        <p14:section name="Mở đầu" id="{d009a2b2-ff51-004a-a875-ce4fe05414dc}">
+        <p14:section name="Mở đầu" id="{bcb32a6f-fce4-3857-db82-a3742f08a6e0}">
           <p14:sldIdLst>
             <p14:sldId id="256"/>
             <p14:sldId id="257"/>
           </p14:sldIdLst>
         </p14:section>
-        <p14:section name="Phân tích và thiết kế" id="{05cdb93d-f563-93b8-aea9-80de5d22f3f0}">
+        <p14:section name="Phân tích và thiết kế" id="{2cf43e74-eafb-98fc-c682-2162363dd4d3}">
           <p14:sldIdLst>
             <p14:sldId id="258"/>
             <p14:sldId id="259"/>
             <p14:sldId id="260"/>
           </p14:sldIdLst>
         </p14:section>
-        <p14:section name="Cài đặt" id="{53cc9ad9-e562-2af1-baea-08d112efde0a}">
+        <p14:section name="Cài đặt" id="{64277668-b7dd-8275-ae88-130fc8a8fb54}">
           <p14:sldIdLst>
             <p14:sldId id="261"/>
             <p14:sldId id="262"/>
           </p14:sldIdLst>
         </p14:section>
-        <p14:section name="Kết thúc" id="{015d0677-7837-df97-7e53-7c914259c4bc}">
+        <p14:section name="Kết thúc" id="{44258281-696e-c5b8-09a9-22a2c614d59d}">
           <p14:sldIdLst>
             <p14:sldId id="263"/>
           </p14:sldIdLst>
@@ -806,7 +806,7 @@
           <a:p>
             <a:r>
               <a:rPr lang="en-US" dirty="0"/>
-              <a:t>Slide 4 - Mô hình ER theo ký hiệu Chen: hình chữ nhật là thực thể, hình elip là thuộc tính, hình thoi là quan hệ, 1 và N là bản số. Có 4 thực thể mạnh (PHIM, PHONGCHIEU, SUATCHIEU, KHACHHANG) và 1 thực thể yếu VE. VE không có mã riêng: mỗi vé được xác định bởi suất chiếu và số ghế. Thực thể chủ của VE là SUATCHIEU, quan hệ xác định là 'bán' (hình thoi viền đôi), SoGhe là khóa bộ phận (gạch chân đứt), VE tham gia toàn phần (đường đôi) vì vé nào cũng phải thuộc một suất chiếu. Các quan hệ: PHIM 1-N SUATCHIEU (chiếu), PHONGCHIEU 1-N SUATCHIEU (tại), SUATCHIEU 1-N VE (bán), KHACHHANG 1-N VE (đặt). KHACHHANG và SUATCHIEU có quan hệ N-N thể hiện qua VE; PHIM và PHONGCHIEU N-N qua thực thể kết hợp SUATCHIEU.</a:t>
+              <a:t>Slide 4 - Mô hình ER theo ký hiệu Chen: hình chữ nhật là thực thể, hình elip là thuộc tính, hình thoi là quan hệ, 1 và N là bản số. Có 4 thực thể mạnh (PHIM, PHONGCHIEU, SUATCHIEU, KHACHHANG) và 1 thực thể yếu VE. VE không có mã riêng: mỗi vé được xác định bởi suất chiếu và số ghế. Thực thể chủ của VE là SUATCHIEU, quan hệ xác định là 'bán' (hình thoi viền đôi), SoGhe là khóa bộ phận (gạch chân đứt), VE tham gia toàn phần (đường đôi) vì vé nào cũng phải thuộc một suất chiếu. Trình bày các quan hệ theo số trên hình: (1) PHIM 1-N SUATCHIEU (chiếu), (2) PHONGCHIEU 1-N SUATCHIEU (tại), (3) SUATCHIEU 1-N VE (bán), (4) KHACHHANG 1-N VE (đặt). KHACHHANG và SUATCHIEU có quan hệ N-N thể hiện qua VE; PHIM và PHONGCHIEU N-N qua SUATCHIEU.</a:t>
             </a:r>
             <a:endParaRPr lang="en-US" dirty="0"/>
           </a:p>

</xml_diff>

<commit_message>
Slide 4: caption each relationship and note the N-N pairs
Co-Authored-By: Claude Opus 5.5 <noreply@anthropic.com>
Claude-Session: https://claude.ai/code/session_01Mv7zheFMCNi8CpghoGk7yL
</commit_message>
<xml_diff>
--- a/hqtcsdl-giuaky/quan_ly_rap_phim.pptx
+++ b/hqtcsdl-giuaky/quan_ly_rap_phim.pptx
@@ -114,26 +114,26 @@
   <p:extLst>
     <p:ext uri="{521415D9-36F7-43E2-AB2F-B90AF26B5E84}">
       <p14:sectionLst xmlns:p14="http://schemas.microsoft.com/office/powerpoint/2010/main">
-        <p14:section name="Mở đầu" id="{bcb32a6f-fce4-3857-db82-a3742f08a6e0}">
+        <p14:section name="Mở đầu" id="{83004f3e-3a8b-91a5-b0ce-2ddb5f57b545}">
           <p14:sldIdLst>
             <p14:sldId id="256"/>
             <p14:sldId id="257"/>
           </p14:sldIdLst>
         </p14:section>
-        <p14:section name="Phân tích và thiết kế" id="{2cf43e74-eafb-98fc-c682-2162363dd4d3}">
+        <p14:section name="Phân tích và thiết kế" id="{b1061146-f5c0-0cc0-c571-3c4e206cbb19}">
           <p14:sldIdLst>
             <p14:sldId id="258"/>
             <p14:sldId id="259"/>
             <p14:sldId id="260"/>
           </p14:sldIdLst>
         </p14:section>
-        <p14:section name="Cài đặt" id="{64277668-b7dd-8275-ae88-130fc8a8fb54}">
+        <p14:section name="Cài đặt" id="{44545b59-2f64-629d-9ab3-4269029313ff}">
           <p14:sldIdLst>
             <p14:sldId id="261"/>
             <p14:sldId id="262"/>
           </p14:sldIdLst>
         </p14:section>
-        <p14:section name="Kết thúc" id="{44258281-696e-c5b8-09a9-22a2c614d59d}">
+        <p14:section name="Kết thúc" id="{56e19ad4-13c1-df98-a6db-89486136746a}">
           <p14:sldIdLst>
             <p14:sldId id="263"/>
           </p14:sldIdLst>

</xml_diff>

<commit_message>
Slide 4: move relationship notes into one corner box, drop numbering
Co-Authored-By: Claude Opus 5.5 <noreply@anthropic.com>
Claude-Session: https://claude.ai/code/session_01Mv7zheFMCNi8CpghoGk7yL
</commit_message>
<xml_diff>
--- a/hqtcsdl-giuaky/quan_ly_rap_phim.pptx
+++ b/hqtcsdl-giuaky/quan_ly_rap_phim.pptx
@@ -114,26 +114,26 @@
   <p:extLst>
     <p:ext uri="{521415D9-36F7-43E2-AB2F-B90AF26B5E84}">
       <p14:sectionLst xmlns:p14="http://schemas.microsoft.com/office/powerpoint/2010/main">
-        <p14:section name="Mở đầu" id="{83004f3e-3a8b-91a5-b0ce-2ddb5f57b545}">
+        <p14:section name="Mở đầu" id="{89bee116-5104-a5c1-bae2-b6b912b03376}">
           <p14:sldIdLst>
             <p14:sldId id="256"/>
             <p14:sldId id="257"/>
           </p14:sldIdLst>
         </p14:section>
-        <p14:section name="Phân tích và thiết kế" id="{b1061146-f5c0-0cc0-c571-3c4e206cbb19}">
+        <p14:section name="Phân tích và thiết kế" id="{5df0cf1b-be1e-01ed-0918-0fb75e5e99ac}">
           <p14:sldIdLst>
             <p14:sldId id="258"/>
             <p14:sldId id="259"/>
             <p14:sldId id="260"/>
           </p14:sldIdLst>
         </p14:section>
-        <p14:section name="Cài đặt" id="{44545b59-2f64-629d-9ab3-4269029313ff}">
+        <p14:section name="Cài đặt" id="{1dbfd1a6-3332-44f4-59a4-091f7fb8fc3d}">
           <p14:sldIdLst>
             <p14:sldId id="261"/>
             <p14:sldId id="262"/>
           </p14:sldIdLst>
         </p14:section>
-        <p14:section name="Kết thúc" id="{56e19ad4-13c1-df98-a6db-89486136746a}">
+        <p14:section name="Kết thúc" id="{cfa8948a-724d-acd4-a494-2c8498f3f4bd}">
           <p14:sldIdLst>
             <p14:sldId id="263"/>
           </p14:sldIdLst>
@@ -806,7 +806,7 @@
           <a:p>
             <a:r>
               <a:rPr lang="en-US" dirty="0"/>
-              <a:t>Slide 4 - Mô hình ER theo ký hiệu Chen: hình chữ nhật là thực thể, hình elip là thuộc tính, hình thoi là quan hệ, 1 và N là bản số. Có 4 thực thể mạnh (PHIM, PHONGCHIEU, SUATCHIEU, KHACHHANG) và 1 thực thể yếu VE. VE không có mã riêng: mỗi vé được xác định bởi suất chiếu và số ghế. Thực thể chủ của VE là SUATCHIEU, quan hệ xác định là 'bán' (hình thoi viền đôi), SoGhe là khóa bộ phận (gạch chân đứt), VE tham gia toàn phần (đường đôi) vì vé nào cũng phải thuộc một suất chiếu. Trình bày các quan hệ theo số trên hình: (1) PHIM 1-N SUATCHIEU (chiếu), (2) PHONGCHIEU 1-N SUATCHIEU (tại), (3) SUATCHIEU 1-N VE (bán), (4) KHACHHANG 1-N VE (đặt). KHACHHANG và SUATCHIEU có quan hệ N-N thể hiện qua VE; PHIM và PHONGCHIEU N-N qua SUATCHIEU.</a:t>
+              <a:t>Slide 4 - Mô hình ER theo ký hiệu Chen: hình chữ nhật là thực thể, hình elip là thuộc tính, hình thoi là quan hệ, 1 và N là bản số. Có 4 thực thể mạnh (PHIM, PHONGCHIEU, SUATCHIEU, KHACHHANG) và 1 thực thể yếu VE. VE không có mã riêng: mỗi vé được xác định bởi suất chiếu và số ghế. Thực thể chủ của VE là SUATCHIEU, quan hệ xác định là 'bán' (hình thoi viền đôi), SoGhe là khóa bộ phận (gạch chân đứt), VE tham gia toàn phần (đường đôi) vì vé nào cũng phải thuộc một suất chiếu. Các quan hệ (tóm tắt ở khung góc phải): PHIM 1-N SUATCHIEU (chiếu), PHONGCHIEU 1-N SUATCHIEU (tại), SUATCHIEU 1-N VE (bán), KHACHHANG 1-N VE (đặt). KHACHHANG và SUATCHIEU có quan hệ N-N thể hiện qua VE; PHIM và PHONGCHIEU N-N qua SUATCHIEU.</a:t>
             </a:r>
             <a:endParaRPr lang="en-US" dirty="0"/>
           </a:p>

</xml_diff>

<commit_message>
Slide 4: split corner into relationships box and notation legend box
Co-Authored-By: Claude Opus 5.5 <noreply@anthropic.com>
Claude-Session: https://claude.ai/code/session_01Mv7zheFMCNi8CpghoGk7yL
</commit_message>
<xml_diff>
--- a/hqtcsdl-giuaky/quan_ly_rap_phim.pptx
+++ b/hqtcsdl-giuaky/quan_ly_rap_phim.pptx
@@ -114,26 +114,26 @@
   <p:extLst>
     <p:ext uri="{521415D9-36F7-43E2-AB2F-B90AF26B5E84}">
       <p14:sectionLst xmlns:p14="http://schemas.microsoft.com/office/powerpoint/2010/main">
-        <p14:section name="Mở đầu" id="{89bee116-5104-a5c1-bae2-b6b912b03376}">
+        <p14:section name="Mở đầu" id="{0b862bfd-0258-616f-5621-57966c24c479}">
           <p14:sldIdLst>
             <p14:sldId id="256"/>
             <p14:sldId id="257"/>
           </p14:sldIdLst>
         </p14:section>
-        <p14:section name="Phân tích và thiết kế" id="{5df0cf1b-be1e-01ed-0918-0fb75e5e99ac}">
+        <p14:section name="Phân tích và thiết kế" id="{b73e8141-a0ff-e58f-aa48-c5a8fdc29a97}">
           <p14:sldIdLst>
             <p14:sldId id="258"/>
             <p14:sldId id="259"/>
             <p14:sldId id="260"/>
           </p14:sldIdLst>
         </p14:section>
-        <p14:section name="Cài đặt" id="{1dbfd1a6-3332-44f4-59a4-091f7fb8fc3d}">
+        <p14:section name="Cài đặt" id="{b5c3db89-19d7-7267-9be7-17b75662da2e}">
           <p14:sldIdLst>
             <p14:sldId id="261"/>
             <p14:sldId id="262"/>
           </p14:sldIdLst>
         </p14:section>
-        <p14:section name="Kết thúc" id="{cfa8948a-724d-acd4-a494-2c8498f3f4bd}">
+        <p14:section name="Kết thúc" id="{ffd14517-057c-fec8-2293-a6a7fbe8e19a}">
           <p14:sldIdLst>
             <p14:sldId id="263"/>
           </p14:sldIdLst>

</xml_diff>